<commit_message>
feat(epd): incorporar web app interactiva, cronograma actualizado y guia del estudiante
</commit_message>
<xml_diff>
--- a/Temas EB/Sesiones EB/Sesion 06/Sesion 06 - Politicas Activas de Empleo.pptx
+++ b/Temas EB/Sesiones EB/Sesion 06/Sesion 06 - Politicas Activas de Empleo.pptx
@@ -16,7 +16,6 @@
     <p:sldId id="265" r:id="rId10"/>
     <p:sldId id="266" r:id="rId11"/>
     <p:sldId id="267" r:id="rId12"/>
-    <p:sldId id="268" r:id="rId13"/>
   </p:sldIdLst>
   <p:sldSz cx="12192000" cy="6858000"/>
   <p:notesSz cx="6858000" cy="9144000"/>
@@ -3478,125 +3477,872 @@
           </a:p>
         </p:txBody>
       </p:sp>
-      <p:sp>
-        <p:nvSpPr>
-          <p:cNvPr id="4" name="Rounded Rectangle 3"/>
-          <p:cNvSpPr/>
+      <mc:AlternateContent xmlns:mc="http://schemas.openxmlformats.org/markup-compatibility/2006">
+        <mc:Choice xmlns:a14="http://schemas.microsoft.com/office/drawing/2010/main" Requires="a14">
+          <p:sp>
+            <p:nvSpPr>
+              <p:cNvPr id="4" name="Rounded Rectangle 3"/>
+              <p:cNvSpPr/>
+              <p:nvPr/>
+            </p:nvSpPr>
+            <p:spPr>
+              <a:xfrm>
+                <a:off x="731521" y="1645920"/>
+                <a:ext cx="7571232" cy="4663440"/>
+              </a:xfrm>
+              <a:prstGeom prst="roundRect">
+                <a:avLst/>
+              </a:prstGeom>
+              <a:solidFill>
+                <a:srgbClr val="F4F8F5"/>
+              </a:solidFill>
+              <a:ln w="25400">
+                <a:solidFill>
+                  <a:srgbClr val="E98F71"/>
+                </a:solidFill>
+              </a:ln>
+            </p:spPr>
+            <p:style>
+              <a:lnRef idx="1">
+                <a:schemeClr val="accent1"/>
+              </a:lnRef>
+              <a:fillRef idx="3">
+                <a:schemeClr val="accent1"/>
+              </a:fillRef>
+              <a:effectRef idx="2">
+                <a:schemeClr val="accent1"/>
+              </a:effectRef>
+              <a:fontRef idx="minor">
+                <a:schemeClr val="lt1"/>
+              </a:fontRef>
+            </p:style>
+            <p:txBody>
+              <a:bodyPr wrap="square" lIns="365760" tIns="274320" rIns="365760" rtlCol="0" anchor="ctr"/>
+              <a:lstStyle/>
+              <a:p>
+                <a:pPr algn="ctr">
+                  <a:defRPr sz="1900" b="1">
+                    <a:solidFill>
+                      <a:srgbClr val="113927"/>
+                    </a:solidFill>
+                    <a:latin typeface="Outfit"/>
+                  </a:defRPr>
+                </a:pPr>
+                <a:r>
+                  <a:rPr dirty="0"/>
+                  <a:t>Caso de </a:t>
+                </a:r>
+                <a:r>
+                  <a:rPr dirty="0" err="1"/>
+                  <a:t>Aplicación</a:t>
+                </a:r>
+                <a:r>
+                  <a:rPr dirty="0"/>
+                  <a:t>: Plan de Choque </a:t>
+                </a:r>
+                <a:r>
+                  <a:rPr dirty="0" err="1"/>
+                  <a:t>Autonómico</a:t>
+                </a:r>
+                <a:r>
+                  <a:rPr dirty="0"/>
+                  <a:t> de 500 M€</a:t>
+                </a:r>
+              </a:p>
+              <a:p>
+                <a:pPr>
+                  <a:spcBef>
+                    <a:spcPts val="800"/>
+                  </a:spcBef>
+                  <a:defRPr sz="1600" i="1">
+                    <a:solidFill>
+                      <a:srgbClr val="2F3A30"/>
+                    </a:solidFill>
+                    <a:latin typeface="Calibri"/>
+                  </a:defRPr>
+                </a:pPr>
+                <a:r>
+                  <a:rPr sz="1400" dirty="0"/>
+                  <a:t>«Una comunidad </a:t>
+                </a:r>
+                <a:r>
+                  <a:rPr sz="1400" dirty="0" err="1"/>
+                  <a:t>autónoma</a:t>
+                </a:r>
+                <a:r>
+                  <a:rPr sz="1400" dirty="0"/>
+                  <a:t> </a:t>
+                </a:r>
+                <a:r>
+                  <a:rPr sz="1400" dirty="0" err="1"/>
+                  <a:t>aprueba</a:t>
+                </a:r>
+                <a:r>
+                  <a:rPr sz="1400" dirty="0"/>
+                  <a:t> un </a:t>
+                </a:r>
+                <a:r>
+                  <a:rPr sz="1400" dirty="0" err="1"/>
+                  <a:t>presupuesto</a:t>
+                </a:r>
+                <a:r>
+                  <a:rPr sz="1400" dirty="0"/>
+                  <a:t> de 500 M€. Destina el 80% (400 M€) a </a:t>
+                </a:r>
+                <a:r>
+                  <a:rPr sz="1400" dirty="0" err="1"/>
+                  <a:t>subvencionar</a:t>
+                </a:r>
+                <a:r>
+                  <a:rPr sz="1400" dirty="0"/>
+                  <a:t> con 6.000 € a </a:t>
+                </a:r>
+                <a:r>
+                  <a:rPr sz="1400" dirty="0" err="1"/>
+                  <a:t>fondo</a:t>
+                </a:r>
+                <a:r>
+                  <a:rPr sz="1400" dirty="0"/>
+                  <a:t> </a:t>
+                </a:r>
+                <a:r>
+                  <a:rPr sz="1400" dirty="0" err="1"/>
+                  <a:t>perdido</a:t>
+                </a:r>
+                <a:r>
+                  <a:rPr sz="1400" dirty="0"/>
+                  <a:t> </a:t>
+                </a:r>
+                <a:r>
+                  <a:rPr sz="1400" dirty="0" err="1"/>
+                  <a:t>cada</a:t>
+                </a:r>
+                <a:r>
+                  <a:rPr sz="1400" dirty="0"/>
+                  <a:t> </a:t>
+                </a:r>
+                <a:r>
+                  <a:rPr sz="1400" dirty="0" err="1"/>
+                  <a:t>contrato</a:t>
+                </a:r>
+                <a:r>
+                  <a:rPr sz="1400" dirty="0"/>
+                  <a:t> </a:t>
+                </a:r>
+                <a:r>
+                  <a:rPr sz="1400" dirty="0" err="1"/>
+                  <a:t>indefinido</a:t>
+                </a:r>
+                <a:r>
+                  <a:rPr sz="1400" dirty="0"/>
+                  <a:t> </a:t>
+                </a:r>
+                <a:r>
+                  <a:rPr sz="1400" dirty="0" err="1"/>
+                  <a:t>formalizado</a:t>
+                </a:r>
+                <a:r>
+                  <a:rPr sz="1400" dirty="0"/>
+                  <a:t> </a:t>
+                </a:r>
+                <a:r>
+                  <a:rPr sz="1400" dirty="0" err="1"/>
+                  <a:t>por</a:t>
+                </a:r>
+                <a:r>
+                  <a:rPr sz="1400" dirty="0"/>
+                  <a:t> </a:t>
+                </a:r>
+                <a:r>
+                  <a:rPr sz="1400" dirty="0" err="1"/>
+                  <a:t>empresas</a:t>
+                </a:r>
+                <a:r>
+                  <a:rPr sz="1400" dirty="0"/>
+                  <a:t> </a:t>
+                </a:r>
+                <a:r>
+                  <a:rPr sz="1400" dirty="0" err="1"/>
+                  <a:t>privadas</a:t>
+                </a:r>
+                <a:r>
+                  <a:rPr sz="1400" dirty="0"/>
+                  <a:t> y el 20% restante (100 M€) a </a:t>
+                </a:r>
+                <a:r>
+                  <a:rPr sz="1400" dirty="0" err="1"/>
+                  <a:t>financiar</a:t>
+                </a:r>
+                <a:r>
+                  <a:rPr sz="1400" dirty="0"/>
+                  <a:t> </a:t>
+                </a:r>
+                <a:r>
+                  <a:rPr sz="1400" dirty="0" err="1"/>
+                  <a:t>contratos</a:t>
+                </a:r>
+                <a:r>
+                  <a:rPr sz="1400" dirty="0"/>
+                  <a:t> </a:t>
+                </a:r>
+                <a:r>
+                  <a:rPr sz="1400" dirty="0" err="1"/>
+                  <a:t>temporales</a:t>
+                </a:r>
+                <a:r>
+                  <a:rPr sz="1400" dirty="0"/>
+                  <a:t> de 6 meses </a:t>
+                </a:r>
+                <a:r>
+                  <a:rPr sz="1400" dirty="0" err="1"/>
+                  <a:t>en</a:t>
+                </a:r>
+                <a:r>
+                  <a:rPr sz="1400" dirty="0"/>
+                  <a:t> ayuntamientos para </a:t>
+                </a:r>
+                <a:r>
+                  <a:rPr sz="1400" dirty="0" err="1"/>
+                  <a:t>limpieza</a:t>
+                </a:r>
+                <a:r>
+                  <a:rPr sz="1400" dirty="0"/>
+                  <a:t> y </a:t>
+                </a:r>
+                <a:r>
+                  <a:rPr sz="1400" dirty="0" err="1"/>
+                  <a:t>jardinería</a:t>
+                </a:r>
+                <a:r>
+                  <a:rPr sz="1400" dirty="0"/>
+                  <a:t>. Los </a:t>
+                </a:r>
+                <a:r>
+                  <a:rPr sz="1400" dirty="0" err="1"/>
+                  <a:t>servicios</a:t>
+                </a:r>
+                <a:r>
+                  <a:rPr sz="1400" dirty="0"/>
+                  <a:t> de </a:t>
+                </a:r>
+                <a:r>
+                  <a:rPr sz="1400" dirty="0" err="1"/>
+                  <a:t>intermediación</a:t>
+                </a:r>
+                <a:r>
+                  <a:rPr sz="1400" dirty="0"/>
+                  <a:t> y </a:t>
+                </a:r>
+                <a:r>
+                  <a:rPr sz="1400" dirty="0" err="1"/>
+                  <a:t>los</a:t>
+                </a:r>
+                <a:r>
+                  <a:rPr sz="1400" dirty="0"/>
+                  <a:t> </a:t>
+                </a:r>
+                <a:r>
+                  <a:rPr sz="1400" dirty="0" err="1"/>
+                  <a:t>cursos</a:t>
+                </a:r>
+                <a:r>
+                  <a:rPr sz="1400" dirty="0"/>
+                  <a:t> de </a:t>
+                </a:r>
+                <a:r>
+                  <a:rPr sz="1400" dirty="0" err="1"/>
+                  <a:t>recualificación</a:t>
+                </a:r>
+                <a:r>
+                  <a:rPr sz="1400" dirty="0"/>
+                  <a:t> </a:t>
+                </a:r>
+                <a:r>
+                  <a:rPr sz="1400" dirty="0" err="1"/>
+                  <a:t>técnica</a:t>
+                </a:r>
+                <a:r>
+                  <a:rPr sz="1400" dirty="0"/>
+                  <a:t> </a:t>
+                </a:r>
+                <a:r>
+                  <a:rPr sz="1400" dirty="0" err="1"/>
+                  <a:t>reciben</a:t>
+                </a:r>
+                <a:r>
+                  <a:rPr sz="1400" dirty="0"/>
+                  <a:t> 0 €. </a:t>
+                </a:r>
+                <a:r>
+                  <a:rPr sz="1400" dirty="0" err="1"/>
+                  <a:t>Razona</a:t>
+                </a:r>
+                <a:r>
+                  <a:rPr sz="1400" dirty="0"/>
+                  <a:t> con rigor </a:t>
+                </a:r>
+                <a:r>
+                  <a:rPr sz="1400" dirty="0" err="1"/>
+                  <a:t>económico</a:t>
+                </a:r>
+                <a:r>
+                  <a:rPr sz="1400" dirty="0"/>
+                  <a:t> formal:»</a:t>
+                </a:r>
+              </a:p>
+              <a:p>
+                <a:pPr>
+                  <a:spcBef>
+                    <a:spcPts val="1200"/>
+                  </a:spcBef>
+                  <a:defRPr sz="1600" b="1">
+                    <a:solidFill>
+                      <a:srgbClr val="113927"/>
+                    </a:solidFill>
+                    <a:latin typeface="Calibri"/>
+                  </a:defRPr>
+                </a:pPr>
+                <a:r>
+                  <a:rPr sz="1400" dirty="0"/>
+                  <a:t>a) </a:t>
+                </a:r>
+                <a:r>
+                  <a:rPr sz="1400" dirty="0" err="1"/>
+                  <a:t>Efectos</a:t>
+                </a:r>
+                <a:r>
+                  <a:rPr sz="1400" dirty="0"/>
+                  <a:t> no </a:t>
+                </a:r>
+                <a:r>
+                  <a:rPr sz="1400" dirty="0" err="1"/>
+                  <a:t>deseados</a:t>
+                </a:r>
+                <a:r>
+                  <a:rPr sz="1400" dirty="0"/>
+                  <a:t> y </a:t>
+                </a:r>
+                <a:r>
+                  <a:rPr sz="1400" dirty="0" err="1"/>
+                  <a:t>Eficiencia</a:t>
+                </a:r>
+                <a:r>
+                  <a:rPr sz="1400" dirty="0"/>
+                  <a:t>: ¿</a:t>
+                </a:r>
+                <a:r>
+                  <a:rPr sz="1400" dirty="0" err="1"/>
+                  <a:t>Qué</a:t>
+                </a:r>
+                <a:r>
+                  <a:rPr sz="1400" dirty="0"/>
+                  <a:t> </a:t>
+                </a:r>
+                <a:r>
+                  <a:rPr sz="1400" dirty="0" err="1"/>
+                  <a:t>ocurrirá</a:t>
+                </a:r>
+                <a:r>
+                  <a:rPr sz="1400" dirty="0"/>
+                  <a:t> con el </a:t>
+                </a:r>
+                <a:r>
+                  <a:rPr sz="1400" dirty="0" err="1"/>
+                  <a:t>empleo</a:t>
+                </a:r>
+                <a:r>
+                  <a:rPr sz="1400" dirty="0"/>
+                  <a:t> </a:t>
+                </a:r>
+                <a:r>
+                  <a:rPr sz="1400" dirty="0" err="1"/>
+                  <a:t>neto</a:t>
+                </a:r>
+                <a:r>
+                  <a:rPr sz="1400" dirty="0"/>
+                  <a:t> real </a:t>
+                </a:r>
+                <a:r>
+                  <a:rPr sz="1400" dirty="0" err="1"/>
+                  <a:t>generado</a:t>
+                </a:r>
+                <a:r>
+                  <a:rPr sz="1400" dirty="0"/>
+                  <a:t> </a:t>
+                </a:r>
+                <a:r>
+                  <a:rPr sz="1400" dirty="0" err="1"/>
+                  <a:t>por</a:t>
+                </a:r>
+                <a:r>
+                  <a:rPr sz="1400" dirty="0"/>
+                  <a:t> </a:t>
+                </a:r>
+                <a:r>
+                  <a:rPr sz="1400" dirty="0" err="1"/>
+                  <a:t>este</a:t>
+                </a:r>
+                <a:r>
+                  <a:rPr sz="1400" dirty="0"/>
+                  <a:t> plan? Define y </a:t>
+                </a:r>
+                <a:r>
+                  <a:rPr sz="1400" dirty="0" err="1"/>
+                  <a:t>aplica</a:t>
+                </a:r>
+                <a:r>
+                  <a:rPr sz="1400" dirty="0"/>
+                  <a:t> con rigor </a:t>
+                </a:r>
+                <a:r>
+                  <a:rPr sz="1400" dirty="0" err="1"/>
+                  <a:t>los</a:t>
+                </a:r>
+                <a:r>
+                  <a:rPr sz="1400" dirty="0"/>
+                  <a:t> </a:t>
+                </a:r>
+                <a:r>
+                  <a:rPr sz="1400" dirty="0" err="1"/>
+                  <a:t>conceptos</a:t>
+                </a:r>
+                <a:r>
+                  <a:rPr sz="1400" dirty="0"/>
+                  <a:t> de </a:t>
+                </a:r>
+                <a:r>
+                  <a:rPr sz="1400" dirty="0" err="1"/>
+                  <a:t>Efecto</a:t>
+                </a:r>
+                <a:r>
+                  <a:rPr sz="1400" dirty="0"/>
+                  <a:t> Peso Muerto (Deadweight Loss) y </a:t>
+                </a:r>
+                <a:r>
+                  <a:rPr sz="1400" dirty="0" err="1"/>
+                  <a:t>Efecto</a:t>
+                </a:r>
+                <a:r>
+                  <a:rPr sz="1400" dirty="0"/>
+                  <a:t> </a:t>
+                </a:r>
+                <a:r>
+                  <a:rPr sz="1400" dirty="0" err="1"/>
+                  <a:t>Sustitución</a:t>
+                </a:r>
+                <a:r>
+                  <a:rPr sz="1400" dirty="0"/>
+                  <a:t>.</a:t>
+                </a:r>
+              </a:p>
+              <a:p>
+                <a:pPr>
+                  <a:spcBef>
+                    <a:spcPts val="1000"/>
+                  </a:spcBef>
+                  <a:defRPr sz="1600" b="1">
+                    <a:solidFill>
+                      <a:srgbClr val="113927"/>
+                    </a:solidFill>
+                    <a:latin typeface="Calibri"/>
+                  </a:defRPr>
+                </a:pPr>
+                <a:r>
+                  <a:rPr sz="1400" dirty="0"/>
+                  <a:t>b) Curva de Beveridge y </a:t>
+                </a:r>
+                <a:r>
+                  <a:rPr sz="1400" dirty="0" err="1"/>
+                  <a:t>Rediseño</a:t>
+                </a:r>
+                <a:r>
+                  <a:rPr sz="1400" dirty="0"/>
+                  <a:t> de Política Pública: ¿</a:t>
+                </a:r>
+                <a:r>
+                  <a:rPr sz="1400" dirty="0" err="1"/>
+                  <a:t>Logrará</a:t>
+                </a:r>
+                <a:r>
+                  <a:rPr sz="1400" dirty="0"/>
+                  <a:t> </a:t>
+                </a:r>
+                <a:r>
+                  <a:rPr sz="1400" dirty="0" err="1"/>
+                  <a:t>este</a:t>
+                </a:r>
+                <a:r>
+                  <a:rPr sz="1400" dirty="0"/>
+                  <a:t> plan </a:t>
+                </a:r>
+                <a:r>
+                  <a:rPr sz="1400" dirty="0" err="1"/>
+                  <a:t>desplazar</a:t>
+                </a:r>
+                <a:r>
+                  <a:rPr sz="1400" dirty="0"/>
+                  <a:t> la Curva de Beveridge </a:t>
+                </a:r>
+                <a:r>
+                  <a:rPr sz="1400" dirty="0" err="1"/>
+                  <a:t>hacia</a:t>
+                </a:r>
+                <a:r>
+                  <a:rPr sz="1400" dirty="0"/>
+                  <a:t> el </a:t>
+                </a:r>
+                <a:r>
+                  <a:rPr sz="1400" dirty="0" err="1"/>
+                  <a:t>origen</a:t>
+                </a:r>
+                <a:r>
+                  <a:rPr sz="1400" dirty="0"/>
+                  <a:t>? Si </a:t>
+                </a:r>
+                <a:r>
+                  <a:rPr sz="1400" dirty="0" err="1"/>
+                  <a:t>tuvieras</a:t>
+                </a:r>
+                <a:r>
+                  <a:rPr sz="1400" dirty="0"/>
+                  <a:t> </a:t>
+                </a:r>
+                <a:r>
+                  <a:rPr sz="1400" dirty="0" err="1"/>
+                  <a:t>que</a:t>
+                </a:r>
+                <a:r>
+                  <a:rPr sz="1400" dirty="0"/>
+                  <a:t> </a:t>
+                </a:r>
+                <a:r>
+                  <a:rPr sz="1400" dirty="0" err="1"/>
+                  <a:t>rediseñar</a:t>
+                </a:r>
+                <a:r>
+                  <a:rPr sz="1400" dirty="0"/>
+                  <a:t> el </a:t>
+                </a:r>
+                <a:r>
+                  <a:rPr sz="1400" dirty="0" err="1"/>
+                  <a:t>presupuesto</a:t>
+                </a:r>
+                <a:r>
+                  <a:rPr sz="1400" dirty="0"/>
+                  <a:t> para </a:t>
+                </a:r>
+                <a:r>
+                  <a:rPr sz="1400" dirty="0" err="1"/>
+                  <a:t>reducir</a:t>
+                </a:r>
+                <a:r>
+                  <a:rPr sz="1400" dirty="0"/>
+                  <a:t> la </a:t>
+                </a:r>
+                <a:r>
+                  <a:rPr sz="1400" dirty="0" err="1"/>
+                  <a:t>tasa</a:t>
+                </a:r>
+                <a:r>
+                  <a:rPr sz="1400" dirty="0"/>
+                  <a:t> natural de </a:t>
+                </a:r>
+                <a:r>
+                  <a:rPr sz="1400" dirty="0" err="1"/>
+                  <a:t>paro</a:t>
+                </a:r>
+                <a:r>
+                  <a:rPr sz="1400" dirty="0"/>
+                  <a:t> (</a:t>
+                </a:r>
+                <a14:m>
+                  <m:oMath xmlns:m="http://schemas.openxmlformats.org/officeDocument/2006/math">
+                    <m:sSub>
+                      <m:sSubPr>
+                        <m:ctrlPr>
+                          <a:rPr lang="es-ES" sz="1400" i="1" dirty="0" smtClean="0">
+                            <a:latin typeface="Cambria Math" panose="02040503050406030204" pitchFamily="18" charset="0"/>
+                          </a:rPr>
+                        </m:ctrlPr>
+                      </m:sSubPr>
+                      <m:e>
+                        <m:r>
+                          <a:rPr lang="es-ES" sz="1400" i="1" dirty="0" smtClean="0">
+                            <a:latin typeface="Cambria Math" panose="02040503050406030204" pitchFamily="18" charset="0"/>
+                          </a:rPr>
+                          <m:t>𝑢</m:t>
+                        </m:r>
+                      </m:e>
+                      <m:sub>
+                        <m:r>
+                          <a:rPr lang="es-ES" sz="1400" i="1" dirty="0" smtClean="0">
+                            <a:latin typeface="Cambria Math" panose="02040503050406030204" pitchFamily="18" charset="0"/>
+                          </a:rPr>
+                          <m:t>𝑛</m:t>
+                        </m:r>
+                      </m:sub>
+                    </m:sSub>
+                  </m:oMath>
+                </a14:m>
+                <a:r>
+                  <a:rPr sz="1400" dirty="0"/>
+                  <a:t>) de forma </a:t>
+                </a:r>
+                <a:r>
+                  <a:rPr sz="1400" dirty="0" err="1"/>
+                  <a:t>permanente</a:t>
+                </a:r>
+                <a:r>
+                  <a:rPr sz="1400" dirty="0"/>
+                  <a:t> y sin </a:t>
+                </a:r>
+                <a:r>
+                  <a:rPr sz="1400" dirty="0" err="1"/>
+                  <a:t>inflación</a:t>
+                </a:r>
+                <a:r>
+                  <a:rPr sz="1400" dirty="0"/>
+                  <a:t>, ¿</a:t>
+                </a:r>
+                <a:r>
+                  <a:rPr sz="1400" dirty="0" err="1"/>
+                  <a:t>qué</a:t>
+                </a:r>
+                <a:r>
+                  <a:rPr sz="1400" dirty="0"/>
+                  <a:t> </a:t>
+                </a:r>
+                <a:r>
+                  <a:rPr sz="1400" dirty="0" err="1"/>
+                  <a:t>combinación</a:t>
+                </a:r>
+                <a:r>
+                  <a:rPr sz="1400" dirty="0"/>
+                  <a:t> de </a:t>
+                </a:r>
+                <a:r>
+                  <a:rPr sz="1400" dirty="0" err="1"/>
+                  <a:t>instrumentos</a:t>
+                </a:r>
+                <a:r>
+                  <a:rPr sz="1400" dirty="0"/>
+                  <a:t> de </a:t>
+                </a:r>
+                <a:r>
+                  <a:rPr sz="1400" dirty="0" err="1"/>
+                  <a:t>políticas</a:t>
+                </a:r>
+                <a:r>
+                  <a:rPr sz="1400" dirty="0"/>
+                  <a:t> </a:t>
+                </a:r>
+                <a:r>
+                  <a:rPr sz="1400" dirty="0" err="1"/>
+                  <a:t>activas</a:t>
+                </a:r>
+                <a:r>
+                  <a:rPr sz="1400" dirty="0"/>
+                  <a:t> </a:t>
+                </a:r>
+                <a:r>
+                  <a:rPr sz="1400" dirty="0" err="1"/>
+                  <a:t>implementarías</a:t>
+                </a:r>
+                <a:r>
+                  <a:rPr sz="1400" dirty="0"/>
+                  <a:t> y </a:t>
+                </a:r>
+                <a:r>
+                  <a:rPr sz="1400" dirty="0" err="1"/>
+                  <a:t>sobre</a:t>
+                </a:r>
+                <a:r>
+                  <a:rPr sz="1400" dirty="0"/>
+                  <a:t> </a:t>
+                </a:r>
+                <a:r>
+                  <a:rPr sz="1400" dirty="0" err="1"/>
+                  <a:t>qué</a:t>
+                </a:r>
+                <a:r>
+                  <a:rPr sz="1400" dirty="0"/>
+                  <a:t> </a:t>
+                </a:r>
+                <a:r>
+                  <a:rPr sz="1400" dirty="0" err="1"/>
+                  <a:t>componentes</a:t>
+                </a:r>
+                <a:r>
+                  <a:rPr sz="1400" dirty="0"/>
+                  <a:t> de la </a:t>
+                </a:r>
+                <a:r>
+                  <a:rPr sz="1400" dirty="0" err="1"/>
+                  <a:t>función</a:t>
+                </a:r>
+                <a:r>
+                  <a:rPr sz="1400" dirty="0"/>
+                  <a:t> de </a:t>
+                </a:r>
+                <a:r>
+                  <a:rPr sz="1400" dirty="0" err="1"/>
+                  <a:t>emparejamiento</a:t>
+                </a:r>
+                <a:r>
+                  <a:rPr sz="1400" dirty="0"/>
+                  <a:t> </a:t>
+                </a:r>
+                <a:r>
+                  <a:rPr sz="1400" dirty="0" err="1"/>
+                  <a:t>actuarías</a:t>
+                </a:r>
+                <a:r>
+                  <a:rPr sz="1400" dirty="0"/>
+                  <a:t>?</a:t>
+                </a:r>
+              </a:p>
+              <a:p>
+                <a:pPr>
+                  <a:spcBef>
+                    <a:spcPts val="1200"/>
+                  </a:spcBef>
+                  <a:defRPr sz="1500" b="1">
+                    <a:solidFill>
+                      <a:srgbClr val="E98F71"/>
+                    </a:solidFill>
+                    <a:latin typeface="Calibri"/>
+                  </a:defRPr>
+                </a:pPr>
+                <a:r>
+                  <a:rPr sz="1400" dirty="0"/>
+                  <a:t>⚠️ Regla de Oro: </a:t>
+                </a:r>
+                <a:r>
+                  <a:rPr sz="1400" dirty="0" err="1"/>
+                  <a:t>Redacción</a:t>
+                </a:r>
+                <a:r>
+                  <a:rPr sz="1400" dirty="0"/>
+                  <a:t> </a:t>
+                </a:r>
+                <a:r>
+                  <a:rPr sz="1400" dirty="0" err="1"/>
+                  <a:t>exclusiva</a:t>
+                </a:r>
+                <a:r>
+                  <a:rPr sz="1400" dirty="0"/>
+                  <a:t> a mano </a:t>
+                </a:r>
+                <a:r>
+                  <a:rPr sz="1400" dirty="0" err="1"/>
+                  <a:t>en</a:t>
+                </a:r>
+                <a:r>
+                  <a:rPr sz="1400" dirty="0"/>
+                  <a:t> </a:t>
+                </a:r>
+                <a:r>
+                  <a:rPr sz="1400" dirty="0" err="1"/>
+                  <a:t>papel</a:t>
+                </a:r>
+                <a:r>
+                  <a:rPr sz="1400" dirty="0"/>
+                  <a:t> (10 min). Sin </a:t>
+                </a:r>
+                <a:r>
+                  <a:rPr sz="1400" dirty="0" err="1"/>
+                  <a:t>pantallas</a:t>
+                </a:r>
+                <a:r>
+                  <a:rPr sz="1400" dirty="0"/>
+                  <a:t>. Máximo rigor </a:t>
+                </a:r>
+                <a:r>
+                  <a:rPr sz="1400" dirty="0" err="1"/>
+                  <a:t>analítico</a:t>
+                </a:r>
+                <a:r>
+                  <a:rPr sz="1400" dirty="0"/>
+                  <a:t>.</a:t>
+                </a:r>
+              </a:p>
+            </p:txBody>
+          </p:sp>
+        </mc:Choice>
+        <mc:Fallback>
+          <p:sp>
+            <p:nvSpPr>
+              <p:cNvPr id="4" name="Rounded Rectangle 3"/>
+              <p:cNvSpPr>
+                <a:spLocks noRot="1" noChangeAspect="1" noMove="1" noResize="1" noEditPoints="1" noAdjustHandles="1" noChangeArrowheads="1" noChangeShapeType="1" noTextEdit="1"/>
+              </p:cNvSpPr>
+              <p:nvPr/>
+            </p:nvSpPr>
+            <p:spPr>
+              <a:xfrm>
+                <a:off x="731521" y="1645920"/>
+                <a:ext cx="7571232" cy="4663440"/>
+              </a:xfrm>
+              <a:prstGeom prst="roundRect">
+                <a:avLst/>
+              </a:prstGeom>
+              <a:blipFill>
+                <a:blip r:embed="rId2"/>
+                <a:stretch>
+                  <a:fillRect/>
+                </a:stretch>
+              </a:blipFill>
+              <a:ln w="25400">
+                <a:solidFill>
+                  <a:srgbClr val="E98F71"/>
+                </a:solidFill>
+              </a:ln>
+            </p:spPr>
+            <p:txBody>
+              <a:bodyPr/>
+              <a:lstStyle/>
+              <a:p>
+                <a:r>
+                  <a:rPr lang="es-ES">
+                    <a:noFill/>
+                  </a:rPr>
+                  <a:t> </a:t>
+                </a:r>
+              </a:p>
+            </p:txBody>
+          </p:sp>
+        </mc:Fallback>
+      </mc:AlternateContent>
+      <p:pic>
+        <p:nvPicPr>
+          <p:cNvPr id="5" name="Imagen 4" descr="Código QR">
+            <a:extLst>
+              <a:ext uri="{FF2B5EF4-FFF2-40B4-BE49-F238E27FC236}">
+                <a16:creationId xmlns:a16="http://schemas.microsoft.com/office/drawing/2014/main" id="{6A09246E-4C1F-F41A-89D3-312F8FBEC4EC}"/>
+              </a:ext>
+            </a:extLst>
+          </p:cNvPr>
+          <p:cNvPicPr>
+            <a:picLocks noChangeAspect="1"/>
+          </p:cNvPicPr>
           <p:nvPr/>
-        </p:nvSpPr>
+        </p:nvPicPr>
+        <p:blipFill>
+          <a:blip r:embed="rId3"/>
+          <a:stretch>
+            <a:fillRect/>
+          </a:stretch>
+        </p:blipFill>
         <p:spPr>
           <a:xfrm>
-            <a:off x="731520" y="1645920"/>
-            <a:ext cx="10728655" cy="4663440"/>
+            <a:off x="8533638" y="2286000"/>
+            <a:ext cx="3531870" cy="3531870"/>
           </a:xfrm>
-          <a:prstGeom prst="roundRect">
+          <a:prstGeom prst="rect">
             <a:avLst/>
           </a:prstGeom>
-          <a:solidFill>
-            <a:srgbClr val="F4F8F5"/>
-          </a:solidFill>
-          <a:ln w="25400">
-            <a:solidFill>
-              <a:srgbClr val="E98F71"/>
-            </a:solidFill>
-          </a:ln>
         </p:spPr>
-        <p:style>
-          <a:lnRef idx="1">
-            <a:schemeClr val="accent1"/>
-          </a:lnRef>
-          <a:fillRef idx="3">
-            <a:schemeClr val="accent1"/>
-          </a:fillRef>
-          <a:effectRef idx="2">
-            <a:schemeClr val="accent1"/>
-          </a:effectRef>
-          <a:fontRef idx="minor">
-            <a:schemeClr val="lt1"/>
-          </a:fontRef>
-        </p:style>
-        <p:txBody>
-          <a:bodyPr wrap="square" lIns="365760" tIns="274320" rIns="365760" rtlCol="0" anchor="ctr"/>
-          <a:lstStyle/>
-          <a:p>
-            <a:pPr algn="ctr">
-              <a:defRPr sz="1900" b="1">
-                <a:solidFill>
-                  <a:srgbClr val="113927"/>
-                </a:solidFill>
-                <a:latin typeface="Outfit"/>
-              </a:defRPr>
-            </a:pPr>
-            <a:r>
-              <a:t>Caso de Aplicación: Plan de Choque Autonómico de 500 M€</a:t>
-            </a:r>
-          </a:p>
-          <a:p>
-            <a:pPr>
-              <a:spcBef>
-                <a:spcPts val="800"/>
-              </a:spcBef>
-              <a:defRPr sz="1600" i="1">
-                <a:solidFill>
-                  <a:srgbClr val="2F3A30"/>
-                </a:solidFill>
-                <a:latin typeface="Calibri"/>
-              </a:defRPr>
-            </a:pPr>
-            <a:r>
-              <a:t>«Una comunidad autónoma aprueba un presupuesto de 500 M€. Destina el 80% (400 M€) a subvencionar con 6.000 € a fondo perdido cada contrato indefinido formalizado por empresas privadas y el 20% restante (100 M€) a financiar contratos temporales de 6 meses en ayuntamientos para limpieza y jardinería. Los servicios de intermediación y los cursos de recualificación técnica reciben 0 €. Razona con rigor económico formal:»</a:t>
-            </a:r>
-          </a:p>
-          <a:p>
-            <a:pPr>
-              <a:spcBef>
-                <a:spcPts val="1200"/>
-              </a:spcBef>
-              <a:defRPr sz="1600" b="1">
-                <a:solidFill>
-                  <a:srgbClr val="113927"/>
-                </a:solidFill>
-                <a:latin typeface="Calibri"/>
-              </a:defRPr>
-            </a:pPr>
-            <a:r>
-              <a:t>a) Efectos no deseados y Eficiencia: ¿Qué ocurrirá con el empleo neto real generado por este plan? Define y aplica con rigor los conceptos de Efecto Peso Muerto (Deadweight Loss) y Efecto Sustitución.</a:t>
-            </a:r>
-          </a:p>
-          <a:p>
-            <a:pPr>
-              <a:spcBef>
-                <a:spcPts val="1000"/>
-              </a:spcBef>
-              <a:defRPr sz="1600" b="1">
-                <a:solidFill>
-                  <a:srgbClr val="113927"/>
-                </a:solidFill>
-                <a:latin typeface="Calibri"/>
-              </a:defRPr>
-            </a:pPr>
-            <a:r>
-              <a:t>b) Curva de Beveridge y Rediseño de Política Pública: ¿Logrará este plan desplazar la Curva de Beveridge hacia el origen? Si tuvieras que rediseñar el presupuesto para reducir la tasa natural de paro (u_n) de forma permanente y sin inflación, ¿qué combinación de instrumentos de políticas activas implementarías y sobre qué componentes de la función de emparejamiento actuarías?</a:t>
-            </a:r>
-          </a:p>
-          <a:p>
-            <a:pPr>
-              <a:spcBef>
-                <a:spcPts val="1200"/>
-              </a:spcBef>
-              <a:defRPr sz="1500" b="1">
-                <a:solidFill>
-                  <a:srgbClr val="E98F71"/>
-                </a:solidFill>
-                <a:latin typeface="Calibri"/>
-              </a:defRPr>
-            </a:pPr>
-            <a:r>
-              <a:t>⚠️ Regla de Oro: Redacción exclusiva a mano en papel (10 min). Sin pantallas. Máximo rigor analítico.</a:t>
-            </a:r>
-          </a:p>
-        </p:txBody>
-      </p:sp>
+      </p:pic>
     </p:spTree>
   </p:cSld>
   <p:clrMapOvr>
@@ -4028,401 +4774,6 @@
 </p:sld>
 </file>
 
-<file path=ppt/slides/slide12.xml><?xml version="1.0" encoding="utf-8"?>
-<p:sld xmlns:a="http://schemas.openxmlformats.org/drawingml/2006/main" xmlns:r="http://schemas.openxmlformats.org/officeDocument/2006/relationships" xmlns:p="http://schemas.openxmlformats.org/presentationml/2006/main">
-  <p:cSld>
-    <p:spTree>
-      <p:nvGrpSpPr>
-        <p:cNvPr id="1" name=""/>
-        <p:cNvGrpSpPr/>
-        <p:nvPr/>
-      </p:nvGrpSpPr>
-      <p:grpSpPr>
-        <a:xfrm>
-          <a:off x="0" y="0"/>
-          <a:ext cx="0" cy="0"/>
-          <a:chOff x="0" y="0"/>
-          <a:chExt cx="0" cy="0"/>
-        </a:xfrm>
-      </p:grpSpPr>
-      <p:sp>
-        <p:nvSpPr>
-          <p:cNvPr id="2" name="TextBox 1"/>
-          <p:cNvSpPr txBox="1"/>
-          <p:nvPr/>
-        </p:nvSpPr>
-        <p:spPr>
-          <a:xfrm>
-            <a:off x="731520" y="365760"/>
-            <a:ext cx="10728655" cy="1005840"/>
-          </a:xfrm>
-          <a:prstGeom prst="rect">
-            <a:avLst/>
-          </a:prstGeom>
-          <a:noFill/>
-        </p:spPr>
-        <p:txBody>
-          <a:bodyPr wrap="square" lIns="0" tIns="0" rIns="0" bIns="0">
-            <a:spAutoFit/>
-          </a:bodyPr>
-          <a:lstStyle/>
-          <a:p>
-            <a:pPr>
-              <a:defRPr sz="1100" b="1">
-                <a:solidFill>
-                  <a:srgbClr val="E98F71"/>
-                </a:solidFill>
-                <a:latin typeface="Outfit"/>
-              </a:defRPr>
-            </a:pPr>
-            <a:r>
-              <a:t>POLÍTICAS SOCIOLABORALES Y DE EMPLEO · TEMA 2 (I)</a:t>
-            </a:r>
-          </a:p>
-          <a:p>
-            <a:pPr>
-              <a:spcBef>
-                <a:spcPts val="300"/>
-              </a:spcBef>
-              <a:defRPr sz="2600" b="1">
-                <a:solidFill>
-                  <a:srgbClr val="113927"/>
-                </a:solidFill>
-                <a:latin typeface="Outfit"/>
-              </a:defRPr>
-            </a:pPr>
-            <a:r>
-              <a:t>Pasaporte de Evaluación Continua y Próximos Pasos</a:t>
-            </a:r>
-          </a:p>
-        </p:txBody>
-      </p:sp>
-      <p:sp>
-        <p:nvSpPr>
-          <p:cNvPr id="3" name="Rectangle 2"/>
-          <p:cNvSpPr/>
-          <p:nvPr/>
-        </p:nvSpPr>
-        <p:spPr>
-          <a:xfrm>
-            <a:off x="731520" y="1417320"/>
-            <a:ext cx="10728655" cy="18288"/>
-          </a:xfrm>
-          <a:prstGeom prst="rect">
-            <a:avLst/>
-          </a:prstGeom>
-          <a:solidFill>
-            <a:srgbClr val="76927A"/>
-          </a:solidFill>
-          <a:ln>
-            <a:noFill/>
-          </a:ln>
-        </p:spPr>
-        <p:style>
-          <a:lnRef idx="1">
-            <a:schemeClr val="accent1"/>
-          </a:lnRef>
-          <a:fillRef idx="3">
-            <a:schemeClr val="accent1"/>
-          </a:fillRef>
-          <a:effectRef idx="2">
-            <a:schemeClr val="accent1"/>
-          </a:effectRef>
-          <a:fontRef idx="minor">
-            <a:schemeClr val="lt1"/>
-          </a:fontRef>
-        </p:style>
-        <p:txBody>
-          <a:bodyPr rtlCol="0" anchor="ctr"/>
-          <a:lstStyle/>
-          <a:p>
-            <a:pPr algn="ctr"/>
-            <a:endParaRPr/>
-          </a:p>
-        </p:txBody>
-      </p:sp>
-      <p:sp>
-        <p:nvSpPr>
-          <p:cNvPr id="4" name="Rounded Rectangle 3"/>
-          <p:cNvSpPr/>
-          <p:nvPr/>
-        </p:nvSpPr>
-        <p:spPr>
-          <a:xfrm>
-            <a:off x="731520" y="1645920"/>
-            <a:ext cx="4114800" cy="4663440"/>
-          </a:xfrm>
-          <a:prstGeom prst="roundRect">
-            <a:avLst/>
-          </a:prstGeom>
-          <a:solidFill>
-            <a:srgbClr val="F4F8F5"/>
-          </a:solidFill>
-          <a:ln w="12700">
-            <a:solidFill>
-              <a:srgbClr val="113927"/>
-            </a:solidFill>
-          </a:ln>
-        </p:spPr>
-        <p:style>
-          <a:lnRef idx="1">
-            <a:schemeClr val="accent1"/>
-          </a:lnRef>
-          <a:fillRef idx="3">
-            <a:schemeClr val="accent1"/>
-          </a:fillRef>
-          <a:effectRef idx="2">
-            <a:schemeClr val="accent1"/>
-          </a:effectRef>
-          <a:fontRef idx="minor">
-            <a:schemeClr val="lt1"/>
-          </a:fontRef>
-        </p:style>
-        <p:txBody>
-          <a:bodyPr wrap="square" lIns="182880" tIns="274320" rIns="182880" rtlCol="0" anchor="ctr"/>
-          <a:lstStyle/>
-          <a:p>
-            <a:pPr algn="ctr">
-              <a:defRPr sz="1800" b="1">
-                <a:solidFill>
-                  <a:srgbClr val="113927"/>
-                </a:solidFill>
-                <a:latin typeface="Outfit"/>
-              </a:defRPr>
-            </a:pPr>
-            <a:r>
-              <a:t>Pasaporte de Evaluación</a:t>
-            </a:r>
-          </a:p>
-        </p:txBody>
-      </p:sp>
-      <p:pic>
-        <p:nvPicPr>
-          <p:cNvPr id="5" name="Picture 4" descr="qr_pasaporte_psll.png"/>
-          <p:cNvPicPr>
-            <a:picLocks noChangeAspect="1"/>
-          </p:cNvPicPr>
-          <p:nvPr/>
-        </p:nvPicPr>
-        <p:blipFill>
-          <a:blip r:embed="rId2"/>
-          <a:stretch>
-            <a:fillRect/>
-          </a:stretch>
-        </p:blipFill>
-        <p:spPr>
-          <a:xfrm>
-            <a:off x="1417320" y="2377440"/>
-            <a:ext cx="2743200" cy="2743200"/>
-          </a:xfrm>
-          <a:prstGeom prst="rect">
-            <a:avLst/>
-          </a:prstGeom>
-        </p:spPr>
-      </p:pic>
-      <p:sp>
-        <p:nvSpPr>
-          <p:cNvPr id="6" name="TextBox 5"/>
-          <p:cNvSpPr txBox="1"/>
-          <p:nvPr/>
-        </p:nvSpPr>
-        <p:spPr>
-          <a:xfrm>
-            <a:off x="731520" y="5303520"/>
-            <a:ext cx="4114800" cy="822960"/>
-          </a:xfrm>
-          <a:prstGeom prst="rect">
-            <a:avLst/>
-          </a:prstGeom>
-          <a:noFill/>
-        </p:spPr>
-        <p:txBody>
-          <a:bodyPr wrap="square">
-            <a:spAutoFit/>
-          </a:bodyPr>
-          <a:lstStyle/>
-          <a:p>
-            <a:pPr algn="ctr">
-              <a:defRPr sz="1500">
-                <a:solidFill>
-                  <a:srgbClr val="113927"/>
-                </a:solidFill>
-                <a:latin typeface="Calibri"/>
-              </a:defRPr>
-            </a:pPr>
-            <a:r>
-              <a:t>Consulta tus calificaciones y feedback</a:t>
-            </a:r>
-            <a:br/>
-            <a:r>
-              <a:t>Cifrado Zero-Knowledge AES-GCM</a:t>
-            </a:r>
-          </a:p>
-        </p:txBody>
-      </p:sp>
-      <p:sp>
-        <p:nvSpPr>
-          <p:cNvPr id="7" name="Rounded Rectangle 6"/>
-          <p:cNvSpPr/>
-          <p:nvPr/>
-        </p:nvSpPr>
-        <p:spPr>
-          <a:xfrm>
-            <a:off x="5120640" y="1645920"/>
-            <a:ext cx="6339535" cy="4663440"/>
-          </a:xfrm>
-          <a:prstGeom prst="roundRect">
-            <a:avLst/>
-          </a:prstGeom>
-          <a:solidFill>
-            <a:srgbClr val="FFFFFF"/>
-          </a:solidFill>
-          <a:ln w="25400">
-            <a:solidFill>
-              <a:srgbClr val="E98F71"/>
-            </a:solidFill>
-          </a:ln>
-        </p:spPr>
-        <p:style>
-          <a:lnRef idx="1">
-            <a:schemeClr val="accent1"/>
-          </a:lnRef>
-          <a:fillRef idx="3">
-            <a:schemeClr val="accent1"/>
-          </a:fillRef>
-          <a:effectRef idx="2">
-            <a:schemeClr val="accent1"/>
-          </a:effectRef>
-          <a:fontRef idx="minor">
-            <a:schemeClr val="lt1"/>
-          </a:fontRef>
-        </p:style>
-        <p:txBody>
-          <a:bodyPr wrap="square" lIns="274320" tIns="274320" rIns="274320" rtlCol="0" anchor="ctr"/>
-          <a:lstStyle/>
-          <a:p>
-            <a:pPr algn="ctr">
-              <a:defRPr sz="1800" b="1">
-                <a:solidFill>
-                  <a:srgbClr val="E98F71"/>
-                </a:solidFill>
-                <a:latin typeface="Outfit"/>
-              </a:defRPr>
-            </a:pPr>
-            <a:r>
-              <a:t>Hoja de Ruta Inmediata: EB 7 y Lanzamiento EPD 1</a:t>
-            </a:r>
-          </a:p>
-          <a:p>
-            <a:pPr>
-              <a:spcBef>
-                <a:spcPts val="800"/>
-              </a:spcBef>
-            </a:pPr>
-            <a:r>
-              <a:rPr sz="1600" b="1">
-                <a:solidFill>
-                  <a:srgbClr val="113927"/>
-                </a:solidFill>
-                <a:latin typeface="Calibri"/>
-              </a:rPr>
-              <a:t>Sesión EB 7: </a:t>
-            </a:r>
-            <a:r>
-              <a:rPr sz="1600">
-                <a:solidFill>
-                  <a:srgbClr val="2F3A30"/>
-                </a:solidFill>
-                <a:latin typeface="Calibri"/>
-              </a:rPr>
-              <a:t>Profundización en el diseño de incentivos a la contratación (§4), instrumentos (subvención vs. bonificación), variables clave y auditoría empírica.</a:t>
-            </a:r>
-          </a:p>
-          <a:p>
-            <a:pPr>
-              <a:spcBef>
-                <a:spcPts val="800"/>
-              </a:spcBef>
-            </a:pPr>
-            <a:r>
-              <a:rPr sz="1600" b="1">
-                <a:solidFill>
-                  <a:srgbClr val="113927"/>
-                </a:solidFill>
-                <a:latin typeface="Calibri"/>
-              </a:rPr>
-              <a:t>Lanzamiento del Caso 1 de EPD: </a:t>
-            </a:r>
-            <a:r>
-              <a:rPr sz="1600">
-                <a:solidFill>
-                  <a:srgbClr val="2F3A30"/>
-                </a:solidFill>
-                <a:latin typeface="Calibri"/>
-              </a:rPr>
-              <a:t>Auditoría técnica del Programa Emplea-T de la Junta de Andalucía (Líneas 1, 2 y 4 de contratación indefinida).</a:t>
-            </a:r>
-          </a:p>
-          <a:p>
-            <a:pPr>
-              <a:spcBef>
-                <a:spcPts val="800"/>
-              </a:spcBef>
-            </a:pPr>
-            <a:r>
-              <a:rPr sz="1600" b="1">
-                <a:solidFill>
-                  <a:srgbClr val="113927"/>
-                </a:solidFill>
-                <a:latin typeface="Calibri"/>
-              </a:rPr>
-              <a:t>Aplicación práctica del instrumental: </a:t>
-            </a:r>
-            <a:r>
-              <a:rPr sz="1600">
-                <a:solidFill>
-                  <a:srgbClr val="2F3A30"/>
-                </a:solidFill>
-                <a:latin typeface="Calibri"/>
-              </a:rPr>
-              <a:t>Calcularás el coste por empleo neto adicional y evaluarás los filtros anti-peso muerto diseñados por la administración pública.</a:t>
-            </a:r>
-          </a:p>
-          <a:p>
-            <a:pPr>
-              <a:spcBef>
-                <a:spcPts val="800"/>
-              </a:spcBef>
-            </a:pPr>
-            <a:r>
-              <a:rPr sz="1600" b="1">
-                <a:solidFill>
-                  <a:srgbClr val="113927"/>
-                </a:solidFill>
-                <a:latin typeface="Calibri"/>
-              </a:rPr>
-              <a:t>Estudio con Apuntes Oficiales: </a:t>
-            </a:r>
-            <a:r>
-              <a:rPr sz="1600">
-                <a:solidFill>
-                  <a:srgbClr val="2F3A30"/>
-                </a:solidFill>
-                <a:latin typeface="Calibri"/>
-              </a:rPr>
-              <a:t>Revisa el Epígrafe 4 del Tema 2 para preparar el debate y el trabajo en equipo de la primera sesión práctica EPD.</a:t>
-            </a:r>
-          </a:p>
-        </p:txBody>
-      </p:sp>
-    </p:spTree>
-  </p:cSld>
-  <p:clrMapOvr>
-    <a:masterClrMapping/>
-  </p:clrMapOvr>
-</p:sld>
-</file>
-
 <file path=ppt/slides/slide2.xml><?xml version="1.0" encoding="utf-8"?>
 <p:sld xmlns:a="http://schemas.openxmlformats.org/drawingml/2006/main" xmlns:r="http://schemas.openxmlformats.org/officeDocument/2006/relationships" xmlns:p="http://schemas.openxmlformats.org/presentationml/2006/main">
   <p:cSld>
@@ -5728,8 +6079,22 @@
               </a:defRPr>
             </a:pPr>
             <a:r>
-              <a:t>El Dilema del Ministro/a de Trabajo</a:t>
-            </a:r>
+              <a:rPr dirty="0"/>
+              <a:t>El </a:t>
+            </a:r>
+            <a:r>
+              <a:rPr dirty="0" err="1"/>
+              <a:t>Dilema</a:t>
+            </a:r>
+            <a:r>
+              <a:rPr dirty="0"/>
+              <a:t> del Ministro/a de </a:t>
+            </a:r>
+            <a:r>
+              <a:rPr dirty="0" err="1"/>
+              <a:t>Trabajo</a:t>
+            </a:r>
+            <a:endParaRPr dirty="0"/>
           </a:p>
           <a:p>
             <a:pPr>
@@ -5744,8 +6109,110 @@
               </a:defRPr>
             </a:pPr>
             <a:r>
-              <a:t>«Dispones de 2.000 M€ extraordinarios para reducir el paro juvenil y de larga duración. ¿Cuál de estas 4 medidas generará mayor empleo neto real?»</a:t>
-            </a:r>
+              <a:rPr dirty="0"/>
+              <a:t>«Dispones de 2.000 M€ </a:t>
+            </a:r>
+            <a:r>
+              <a:rPr dirty="0" err="1"/>
+              <a:t>extraordinarios</a:t>
+            </a:r>
+            <a:r>
+              <a:rPr dirty="0"/>
+              <a:t> para </a:t>
+            </a:r>
+            <a:r>
+              <a:rPr dirty="0" err="1"/>
+              <a:t>reducir</a:t>
+            </a:r>
+            <a:r>
+              <a:rPr dirty="0"/>
+              <a:t> el </a:t>
+            </a:r>
+            <a:r>
+              <a:rPr dirty="0" err="1"/>
+              <a:t>paro</a:t>
+            </a:r>
+            <a:r>
+              <a:rPr dirty="0"/>
+              <a:t> </a:t>
+            </a:r>
+            <a:r>
+              <a:rPr dirty="0" err="1"/>
+              <a:t>juvenil</a:t>
+            </a:r>
+            <a:r>
+              <a:rPr dirty="0"/>
+              <a:t> y de </a:t>
+            </a:r>
+            <a:r>
+              <a:rPr dirty="0" err="1"/>
+              <a:t>larga</a:t>
+            </a:r>
+            <a:r>
+              <a:rPr dirty="0"/>
+              <a:t> </a:t>
+            </a:r>
+            <a:r>
+              <a:rPr dirty="0" err="1"/>
+              <a:t>duración</a:t>
+            </a:r>
+            <a:r>
+              <a:rPr dirty="0"/>
+              <a:t>. ¿</a:t>
+            </a:r>
+            <a:r>
+              <a:rPr dirty="0" err="1"/>
+              <a:t>Cuál</a:t>
+            </a:r>
+            <a:r>
+              <a:rPr dirty="0"/>
+              <a:t> de </a:t>
+            </a:r>
+            <a:r>
+              <a:rPr dirty="0" err="1"/>
+              <a:t>estas</a:t>
+            </a:r>
+            <a:r>
+              <a:rPr dirty="0"/>
+              <a:t> 4 </a:t>
+            </a:r>
+            <a:r>
+              <a:rPr dirty="0" err="1"/>
+              <a:t>medidas</a:t>
+            </a:r>
+            <a:r>
+              <a:rPr dirty="0"/>
+              <a:t> </a:t>
+            </a:r>
+            <a:r>
+              <a:rPr dirty="0" err="1"/>
+              <a:t>generará</a:t>
+            </a:r>
+            <a:r>
+              <a:rPr dirty="0"/>
+              <a:t> mayor </a:t>
+            </a:r>
+            <a:r>
+              <a:rPr dirty="0" err="1"/>
+              <a:t>empleo</a:t>
+            </a:r>
+            <a:r>
+              <a:rPr dirty="0"/>
+              <a:t> </a:t>
+            </a:r>
+            <a:r>
+              <a:rPr dirty="0" err="1"/>
+              <a:t>neto</a:t>
+            </a:r>
+            <a:r>
+              <a:rPr dirty="0"/>
+              <a:t> real?»</a:t>
+            </a:r>
+            <a:endParaRPr dirty="0">
+              <a:solidFill>
+                <a:schemeClr val="tx1"/>
+              </a:solidFill>
+            </a:endParaRPr>
           </a:p>
           <a:p>
             <a:pPr>
@@ -5754,14 +6221,36 @@
               </a:spcBef>
             </a:pPr>
             <a:r>
-              <a:rPr sz="1600" b="1">
-                <a:solidFill>
-                  <a:srgbClr val="113927"/>
+              <a:rPr sz="1600" b="1" dirty="0">
+                <a:solidFill>
+                  <a:schemeClr val="tx1"/>
                 </a:solidFill>
                 <a:latin typeface="Calibri"/>
               </a:rPr>
               <a:t>A) </a:t>
             </a:r>
+            <a:r>
+              <a:rPr lang="es-ES" dirty="0">
+                <a:solidFill>
+                  <a:schemeClr val="tx1"/>
+                </a:solidFill>
+              </a:rPr>
+              <a:t>Subvencionar con 4.000 € a fondo perdido a cualquier empresa que contrate a un joven. </a:t>
+            </a:r>
+            <a:r>
+              <a:rPr lang="es-ES" i="1" dirty="0">
+                <a:solidFill>
+                  <a:schemeClr val="tx1"/>
+                </a:solidFill>
+              </a:rPr>
+              <a:t>(El 70% se habría contratado igual).</a:t>
+            </a:r>
+            <a:endParaRPr sz="1600" b="1" dirty="0">
+              <a:solidFill>
+                <a:schemeClr val="tx1"/>
+              </a:solidFill>
+              <a:latin typeface="Calibri"/>
+            </a:endParaRPr>
           </a:p>
           <a:p>
             <a:pPr>
@@ -5770,14 +6259,28 @@
               </a:spcBef>
             </a:pPr>
             <a:r>
-              <a:rPr sz="1600" b="1">
-                <a:solidFill>
-                  <a:srgbClr val="113927"/>
+              <a:rPr sz="1600" b="1" dirty="0">
+                <a:solidFill>
+                  <a:schemeClr val="tx1"/>
                 </a:solidFill>
                 <a:latin typeface="Calibri"/>
               </a:rPr>
               <a:t>B) </a:t>
             </a:r>
+            <a:r>
+              <a:rPr lang="es-ES" dirty="0">
+                <a:solidFill>
+                  <a:schemeClr val="tx1"/>
+                </a:solidFill>
+              </a:rPr>
+              <a:t>Cursos masivos de formación general sin coordinar con empresas.</a:t>
+            </a:r>
+            <a:endParaRPr sz="1600" b="1" dirty="0">
+              <a:solidFill>
+                <a:schemeClr val="tx1"/>
+              </a:solidFill>
+              <a:latin typeface="Calibri"/>
+            </a:endParaRPr>
           </a:p>
           <a:p>
             <a:pPr>
@@ -5786,14 +6289,28 @@
               </a:spcBef>
             </a:pPr>
             <a:r>
-              <a:rPr sz="1600" b="1">
-                <a:solidFill>
-                  <a:srgbClr val="113927"/>
+              <a:rPr sz="1600" b="1" dirty="0">
+                <a:solidFill>
+                  <a:schemeClr val="tx1"/>
                 </a:solidFill>
                 <a:latin typeface="Calibri"/>
               </a:rPr>
               <a:t>C) </a:t>
             </a:r>
+            <a:r>
+              <a:rPr lang="es-ES" dirty="0">
+                <a:solidFill>
+                  <a:schemeClr val="tx1"/>
+                </a:solidFill>
+              </a:rPr>
+              <a:t>Aumentar cuantía y duración de los subsidios asistenciales.</a:t>
+            </a:r>
+            <a:endParaRPr sz="1600" b="1" dirty="0">
+              <a:solidFill>
+                <a:schemeClr val="tx1"/>
+              </a:solidFill>
+              <a:latin typeface="Calibri"/>
+            </a:endParaRPr>
           </a:p>
           <a:p>
             <a:pPr>
@@ -5802,14 +6319,28 @@
               </a:spcBef>
             </a:pPr>
             <a:r>
-              <a:rPr sz="1600" b="1">
-                <a:solidFill>
-                  <a:srgbClr val="113927"/>
+              <a:rPr sz="1600" b="1" dirty="0">
+                <a:solidFill>
+                  <a:schemeClr val="tx1"/>
                 </a:solidFill>
                 <a:latin typeface="Calibri"/>
               </a:rPr>
               <a:t>D) </a:t>
             </a:r>
+            <a:r>
+              <a:rPr lang="es-ES" dirty="0">
+                <a:solidFill>
+                  <a:schemeClr val="tx1"/>
+                </a:solidFill>
+              </a:rPr>
+              <a:t>Itinerarios de orientación personalizada con perfilado algorítmico y formación dual comprometida con vacantes reales.</a:t>
+            </a:r>
+            <a:endParaRPr sz="1600" b="1" dirty="0">
+              <a:solidFill>
+                <a:schemeClr val="tx1"/>
+              </a:solidFill>
+              <a:latin typeface="Calibri"/>
+            </a:endParaRPr>
           </a:p>
         </p:txBody>
       </p:sp>
@@ -5868,9 +6399,55 @@
           </a:p>
         </p:txBody>
       </p:sp>
+      <p:sp>
+        <p:nvSpPr>
+          <p:cNvPr id="7" name="TextBox 6"/>
+          <p:cNvSpPr txBox="1"/>
+          <p:nvPr/>
+        </p:nvSpPr>
+        <p:spPr>
+          <a:xfrm>
+            <a:off x="8138160" y="5120640"/>
+            <a:ext cx="3291840" cy="1005840"/>
+          </a:xfrm>
+          <a:prstGeom prst="rect">
+            <a:avLst/>
+          </a:prstGeom>
+          <a:noFill/>
+        </p:spPr>
+        <p:txBody>
+          <a:bodyPr wrap="square">
+            <a:spAutoFit/>
+          </a:bodyPr>
+          <a:lstStyle/>
+          <a:p>
+            <a:pPr algn="ctr">
+              <a:defRPr sz="1500">
+                <a:solidFill>
+                  <a:srgbClr val="113927"/>
+                </a:solidFill>
+                <a:latin typeface="Calibri"/>
+              </a:defRPr>
+            </a:pPr>
+            <a:r>
+              <a:t>Escanea el código QR</a:t>
+            </a:r>
+            <a:br/>
+            <a:r>
+              <a:t>Sondeo anónimo y formativo</a:t>
+            </a:r>
+          </a:p>
+        </p:txBody>
+      </p:sp>
       <p:pic>
         <p:nvPicPr>
-          <p:cNvPr id="6" name="Picture 5" descr="qr_sondeo_sesion06.png"/>
+          <p:cNvPr id="8" name="Imagen 7" descr="Código QR">
+            <a:extLst>
+              <a:ext uri="{FF2B5EF4-FFF2-40B4-BE49-F238E27FC236}">
+                <a16:creationId xmlns:a16="http://schemas.microsoft.com/office/drawing/2014/main" id="{F00EBEFB-0089-B6EC-4702-867073FA16B6}"/>
+              </a:ext>
+            </a:extLst>
+          </p:cNvPr>
           <p:cNvPicPr>
             <a:picLocks noChangeAspect="1"/>
           </p:cNvPicPr>
@@ -5884,54 +6461,14 @@
         </p:blipFill>
         <p:spPr>
           <a:xfrm>
-            <a:off x="8503920" y="2377440"/>
-            <a:ext cx="2560320" cy="2560320"/>
+            <a:off x="8346948" y="2072640"/>
+            <a:ext cx="2874264" cy="2874264"/>
           </a:xfrm>
           <a:prstGeom prst="rect">
             <a:avLst/>
           </a:prstGeom>
         </p:spPr>
       </p:pic>
-      <p:sp>
-        <p:nvSpPr>
-          <p:cNvPr id="7" name="TextBox 6"/>
-          <p:cNvSpPr txBox="1"/>
-          <p:nvPr/>
-        </p:nvSpPr>
-        <p:spPr>
-          <a:xfrm>
-            <a:off x="8138160" y="5120640"/>
-            <a:ext cx="3291840" cy="1005840"/>
-          </a:xfrm>
-          <a:prstGeom prst="rect">
-            <a:avLst/>
-          </a:prstGeom>
-          <a:noFill/>
-        </p:spPr>
-        <p:txBody>
-          <a:bodyPr wrap="square">
-            <a:spAutoFit/>
-          </a:bodyPr>
-          <a:lstStyle/>
-          <a:p>
-            <a:pPr algn="ctr">
-              <a:defRPr sz="1500">
-                <a:solidFill>
-                  <a:srgbClr val="113927"/>
-                </a:solidFill>
-                <a:latin typeface="Calibri"/>
-              </a:defRPr>
-            </a:pPr>
-            <a:r>
-              <a:t>Escanea el código QR</a:t>
-            </a:r>
-            <a:br/>
-            <a:r>
-              <a:t>Sondeo anónimo y formativo</a:t>
-            </a:r>
-          </a:p>
-        </p:txBody>
-      </p:sp>
     </p:spTree>
   </p:cSld>
   <p:clrMapOvr>
@@ -7298,7 +7835,32 @@
               </a:defRPr>
             </a:pPr>
             <a:r>
-              <a:t>La Función de Emparejamiento y el Parámetro A</a:t>
+              <a:rPr dirty="0"/>
+              <a:t>La </a:t>
+            </a:r>
+            <a:r>
+              <a:rPr dirty="0" err="1"/>
+              <a:t>Función</a:t>
+            </a:r>
+            <a:r>
+              <a:rPr dirty="0"/>
+              <a:t> de </a:t>
+            </a:r>
+            <a:r>
+              <a:rPr dirty="0" err="1"/>
+              <a:t>Emparejamiento</a:t>
+            </a:r>
+            <a:r>
+              <a:rPr dirty="0"/>
+              <a:t> y el </a:t>
+            </a:r>
+            <a:r>
+              <a:rPr dirty="0" err="1"/>
+              <a:t>Parámetro</a:t>
+            </a:r>
+            <a:r>
+              <a:rPr dirty="0"/>
+              <a:t> A</a:t>
             </a:r>
           </a:p>
           <a:p>
@@ -7314,6 +7876,7 @@
               </a:defRPr>
             </a:pPr>
             <a:r>
+              <a:rPr dirty="0"/>
               <a:t>m = A · U^α · V^(1-α)</a:t>
             </a:r>
           </a:p>
@@ -7330,7 +7893,64 @@
               </a:defRPr>
             </a:pPr>
             <a:r>
-              <a:t>• A representa la eficiencia tecnológica e institucional del emparejamiento entre desempleados (U) y vacantes (V).</a:t>
+              <a:rPr dirty="0"/>
+              <a:t>• A </a:t>
+            </a:r>
+            <a:r>
+              <a:rPr dirty="0" err="1"/>
+              <a:t>representa</a:t>
+            </a:r>
+            <a:r>
+              <a:rPr dirty="0"/>
+              <a:t> la </a:t>
+            </a:r>
+            <a:r>
+              <a:rPr dirty="0" err="1"/>
+              <a:t>eficiencia</a:t>
+            </a:r>
+            <a:r>
+              <a:rPr dirty="0"/>
+              <a:t> </a:t>
+            </a:r>
+            <a:r>
+              <a:rPr dirty="0" err="1"/>
+              <a:t>tecnológica</a:t>
+            </a:r>
+            <a:r>
+              <a:rPr dirty="0"/>
+              <a:t> e </a:t>
+            </a:r>
+            <a:r>
+              <a:rPr dirty="0" err="1"/>
+              <a:t>institucional</a:t>
+            </a:r>
+            <a:r>
+              <a:rPr dirty="0"/>
+              <a:t> del </a:t>
+            </a:r>
+            <a:r>
+              <a:rPr dirty="0" err="1"/>
+              <a:t>emparejamiento</a:t>
+            </a:r>
+            <a:r>
+              <a:rPr dirty="0"/>
+              <a:t> entre </a:t>
+            </a:r>
+            <a:r>
+              <a:rPr dirty="0" err="1"/>
+              <a:t>desempleados</a:t>
+            </a:r>
+            <a:r>
+              <a:rPr dirty="0"/>
+              <a:t> (U) y </a:t>
+            </a:r>
+            <a:r>
+              <a:rPr dirty="0" err="1"/>
+              <a:t>vacantes</a:t>
+            </a:r>
+            <a:r>
+              <a:rPr dirty="0"/>
+              <a:t> (V).</a:t>
             </a:r>
           </a:p>
           <a:p>
@@ -7346,7 +7966,96 @@
               </a:defRPr>
             </a:pPr>
             <a:r>
-              <a:t>• Las políticas de demanda (gasto público tradicional) solo provocan movimientos a lo largo de la curva: más vacantes pero a costa de inflación.</a:t>
+              <a:rPr dirty="0"/>
+              <a:t>• Las </a:t>
+            </a:r>
+            <a:r>
+              <a:rPr dirty="0" err="1"/>
+              <a:t>políticas</a:t>
+            </a:r>
+            <a:r>
+              <a:rPr dirty="0"/>
+              <a:t> de </a:t>
+            </a:r>
+            <a:r>
+              <a:rPr dirty="0" err="1"/>
+              <a:t>demanda</a:t>
+            </a:r>
+            <a:r>
+              <a:rPr dirty="0"/>
+              <a:t> (</a:t>
+            </a:r>
+            <a:r>
+              <a:rPr dirty="0" err="1"/>
+              <a:t>gasto</a:t>
+            </a:r>
+            <a:r>
+              <a:rPr dirty="0"/>
+              <a:t> </a:t>
+            </a:r>
+            <a:r>
+              <a:rPr dirty="0" err="1"/>
+              <a:t>público</a:t>
+            </a:r>
+            <a:r>
+              <a:rPr dirty="0"/>
+              <a:t> </a:t>
+            </a:r>
+            <a:r>
+              <a:rPr dirty="0" err="1"/>
+              <a:t>tradicional</a:t>
+            </a:r>
+            <a:r>
+              <a:rPr dirty="0"/>
+              <a:t>) solo </a:t>
+            </a:r>
+            <a:r>
+              <a:rPr dirty="0" err="1"/>
+              <a:t>provocan</a:t>
+            </a:r>
+            <a:r>
+              <a:rPr dirty="0"/>
+              <a:t> </a:t>
+            </a:r>
+            <a:r>
+              <a:rPr dirty="0" err="1"/>
+              <a:t>movimientos</a:t>
+            </a:r>
+            <a:r>
+              <a:rPr dirty="0"/>
+              <a:t> a lo largo de la curva: </a:t>
+            </a:r>
+            <a:r>
+              <a:rPr dirty="0" err="1"/>
+              <a:t>más</a:t>
+            </a:r>
+            <a:r>
+              <a:rPr dirty="0"/>
+              <a:t> </a:t>
+            </a:r>
+            <a:r>
+              <a:rPr lang="es-ES" dirty="0"/>
+              <a:t>vacantes,</a:t>
+            </a:r>
+            <a:r>
+              <a:rPr dirty="0"/>
+              <a:t> </a:t>
+            </a:r>
+            <a:r>
+              <a:rPr dirty="0" err="1"/>
+              <a:t>pero</a:t>
+            </a:r>
+            <a:r>
+              <a:rPr dirty="0"/>
+              <a:t> a costa de </a:t>
+            </a:r>
+            <a:r>
+              <a:rPr dirty="0" err="1"/>
+              <a:t>inflación</a:t>
+            </a:r>
+            <a:r>
+              <a:rPr dirty="0"/>
+              <a:t>.</a:t>
             </a:r>
           </a:p>
           <a:p>
@@ -7362,7 +8071,64 @@
               </a:defRPr>
             </a:pPr>
             <a:r>
-              <a:t>• Las Políticas Activas de Oferta (orientación y formación) aumentan el parámetro de eficiencia: A ↑.</a:t>
+              <a:rPr dirty="0"/>
+              <a:t>• Las </a:t>
+            </a:r>
+            <a:r>
+              <a:rPr dirty="0" err="1"/>
+              <a:t>Políticas</a:t>
+            </a:r>
+            <a:r>
+              <a:rPr dirty="0"/>
+              <a:t> Activas de </a:t>
+            </a:r>
+            <a:r>
+              <a:rPr dirty="0" err="1"/>
+              <a:t>Oferta</a:t>
+            </a:r>
+            <a:r>
+              <a:rPr dirty="0"/>
+              <a:t> (</a:t>
+            </a:r>
+            <a:r>
+              <a:rPr dirty="0" err="1"/>
+              <a:t>orientación</a:t>
+            </a:r>
+            <a:r>
+              <a:rPr dirty="0"/>
+              <a:t> y </a:t>
+            </a:r>
+            <a:r>
+              <a:rPr dirty="0" err="1"/>
+              <a:t>formación</a:t>
+            </a:r>
+            <a:r>
+              <a:rPr dirty="0"/>
+              <a:t>) </a:t>
+            </a:r>
+            <a:r>
+              <a:rPr dirty="0" err="1"/>
+              <a:t>aumentan</a:t>
+            </a:r>
+            <a:r>
+              <a:rPr dirty="0"/>
+              <a:t> el </a:t>
+            </a:r>
+            <a:r>
+              <a:rPr dirty="0" err="1"/>
+              <a:t>parámetro</a:t>
+            </a:r>
+            <a:r>
+              <a:rPr dirty="0"/>
+              <a:t> de </a:t>
+            </a:r>
+            <a:r>
+              <a:rPr dirty="0" err="1"/>
+              <a:t>eficiencia</a:t>
+            </a:r>
+            <a:r>
+              <a:rPr dirty="0"/>
+              <a:t>: A ↑.</a:t>
             </a:r>
           </a:p>
           <a:p>
@@ -7378,130 +8144,662 @@
               </a:defRPr>
             </a:pPr>
             <a:r>
-              <a:t>• Consecuencia geométrica: La Curva de Beveridge se desplaza hacia el origen, logrando menor desempleo u para el mismo volumen de vacantes v.</a:t>
-            </a:r>
-          </a:p>
-        </p:txBody>
-      </p:sp>
-      <p:sp>
-        <p:nvSpPr>
-          <p:cNvPr id="5" name="Rounded Rectangle 4"/>
-          <p:cNvSpPr/>
-          <p:nvPr/>
-        </p:nvSpPr>
-        <p:spPr>
-          <a:xfrm>
-            <a:off x="6309360" y="1645920"/>
-            <a:ext cx="5150815" cy="4663440"/>
-          </a:xfrm>
-          <a:prstGeom prst="roundRect">
-            <a:avLst/>
-          </a:prstGeom>
-          <a:solidFill>
-            <a:srgbClr val="F4F8F5"/>
-          </a:solidFill>
-          <a:ln w="12700">
-            <a:solidFill>
-              <a:srgbClr val="76927A"/>
-            </a:solidFill>
-          </a:ln>
-        </p:spPr>
-        <p:style>
-          <a:lnRef idx="1">
-            <a:schemeClr val="accent1"/>
-          </a:lnRef>
-          <a:fillRef idx="3">
-            <a:schemeClr val="accent1"/>
-          </a:fillRef>
-          <a:effectRef idx="2">
-            <a:schemeClr val="accent1"/>
-          </a:effectRef>
-          <a:fontRef idx="minor">
-            <a:schemeClr val="lt1"/>
-          </a:fontRef>
-        </p:style>
-        <p:txBody>
-          <a:bodyPr wrap="square" lIns="274320" tIns="274320" rIns="274320" rtlCol="0" anchor="ctr"/>
-          <a:lstStyle/>
-          <a:p>
-            <a:pPr algn="ctr">
-              <a:defRPr sz="1800" b="1">
-                <a:solidFill>
-                  <a:srgbClr val="113927"/>
-                </a:solidFill>
-                <a:latin typeface="Outfit"/>
-              </a:defRPr>
-            </a:pPr>
-            <a:r>
-              <a:t>¿Cómo Reducir la NAIRU sin Inflación?</a:t>
-            </a:r>
-          </a:p>
-          <a:p>
-            <a:pPr>
-              <a:spcBef>
-                <a:spcPts val="800"/>
-              </a:spcBef>
-              <a:defRPr sz="1600">
-                <a:solidFill>
-                  <a:srgbClr val="2F3A30"/>
-                </a:solidFill>
-                <a:latin typeface="Calibri"/>
-              </a:defRPr>
-            </a:pPr>
-            <a:r>
-              <a:t>• Recordatorio de la Sesión 4: La tasa natural de desempleo viene dada por u_n = u_friccional + u_estructural.</a:t>
-            </a:r>
-          </a:p>
-          <a:p>
-            <a:pPr>
-              <a:spcBef>
-                <a:spcPts val="800"/>
-              </a:spcBef>
-              <a:defRPr sz="1600">
-                <a:solidFill>
-                  <a:srgbClr val="2F3A30"/>
-                </a:solidFill>
-                <a:latin typeface="Calibri"/>
-              </a:defRPr>
-            </a:pPr>
-            <a:r>
-              <a:t>• 1. Orientación e Intermediación Laboral: Reduce las asimetrías de información y los costes de búsqueda → reduce el paro friccional.</a:t>
-            </a:r>
-          </a:p>
-          <a:p>
-            <a:pPr>
-              <a:spcBef>
-                <a:spcPts val="800"/>
-              </a:spcBef>
-              <a:defRPr sz="1600">
-                <a:solidFill>
-                  <a:srgbClr val="2F3A30"/>
-                </a:solidFill>
-                <a:latin typeface="Calibri"/>
-              </a:defRPr>
-            </a:pPr>
-            <a:r>
-              <a:t>• 2. Formación Profesional y Reskilling: Corrige el desajuste de habilidades (skills mismatch) → reduce el paro estructural.</a:t>
-            </a:r>
-          </a:p>
-          <a:p>
-            <a:pPr>
-              <a:spcBef>
-                <a:spcPts val="800"/>
-              </a:spcBef>
-              <a:defRPr sz="1600">
-                <a:solidFill>
-                  <a:srgbClr val="2F3A30"/>
-                </a:solidFill>
-                <a:latin typeface="Calibri"/>
-              </a:defRPr>
-            </a:pPr>
-            <a:r>
-              <a:t>• 3. Resultado macroeconómico formal: El desempleo de equilibrio u* cae de forma permanente sin generar tensiones salariales ni aceleración inflacionista.</a:t>
-            </a:r>
-          </a:p>
-        </p:txBody>
-      </p:sp>
+              <a:rPr dirty="0"/>
+              <a:t>• </a:t>
+            </a:r>
+            <a:r>
+              <a:rPr dirty="0" err="1"/>
+              <a:t>Consecuencia</a:t>
+            </a:r>
+            <a:r>
+              <a:rPr dirty="0"/>
+              <a:t> </a:t>
+            </a:r>
+            <a:r>
+              <a:rPr dirty="0" err="1"/>
+              <a:t>geométrica</a:t>
+            </a:r>
+            <a:r>
+              <a:rPr dirty="0"/>
+              <a:t>: La Curva de Beveridge se </a:t>
+            </a:r>
+            <a:r>
+              <a:rPr dirty="0" err="1"/>
+              <a:t>desplaza</a:t>
+            </a:r>
+            <a:r>
+              <a:rPr dirty="0"/>
+              <a:t> </a:t>
+            </a:r>
+            <a:r>
+              <a:rPr dirty="0" err="1"/>
+              <a:t>hacia</a:t>
+            </a:r>
+            <a:r>
+              <a:rPr dirty="0"/>
+              <a:t> el </a:t>
+            </a:r>
+            <a:r>
+              <a:rPr dirty="0" err="1"/>
+              <a:t>origen</a:t>
+            </a:r>
+            <a:r>
+              <a:rPr dirty="0"/>
+              <a:t>, </a:t>
+            </a:r>
+            <a:r>
+              <a:rPr dirty="0" err="1"/>
+              <a:t>logrando</a:t>
+            </a:r>
+            <a:r>
+              <a:rPr dirty="0"/>
+              <a:t> </a:t>
+            </a:r>
+            <a:r>
+              <a:rPr dirty="0" err="1"/>
+              <a:t>menor</a:t>
+            </a:r>
+            <a:r>
+              <a:rPr dirty="0"/>
+              <a:t> </a:t>
+            </a:r>
+            <a:r>
+              <a:rPr dirty="0" err="1"/>
+              <a:t>desempleo</a:t>
+            </a:r>
+            <a:r>
+              <a:rPr dirty="0"/>
+              <a:t> u para el </a:t>
+            </a:r>
+            <a:r>
+              <a:rPr dirty="0" err="1"/>
+              <a:t>mismo</a:t>
+            </a:r>
+            <a:r>
+              <a:rPr dirty="0"/>
+              <a:t> </a:t>
+            </a:r>
+            <a:r>
+              <a:rPr dirty="0" err="1"/>
+              <a:t>volumen</a:t>
+            </a:r>
+            <a:r>
+              <a:rPr dirty="0"/>
+              <a:t> de </a:t>
+            </a:r>
+            <a:r>
+              <a:rPr dirty="0" err="1"/>
+              <a:t>vacantes</a:t>
+            </a:r>
+            <a:r>
+              <a:rPr dirty="0"/>
+              <a:t> v.</a:t>
+            </a:r>
+          </a:p>
+        </p:txBody>
+      </p:sp>
+      <mc:AlternateContent xmlns:mc="http://schemas.openxmlformats.org/markup-compatibility/2006">
+        <mc:Choice xmlns:a14="http://schemas.microsoft.com/office/drawing/2010/main" Requires="a14">
+          <p:sp>
+            <p:nvSpPr>
+              <p:cNvPr id="5" name="Rounded Rectangle 4"/>
+              <p:cNvSpPr/>
+              <p:nvPr/>
+            </p:nvSpPr>
+            <p:spPr>
+              <a:xfrm>
+                <a:off x="6309360" y="1645920"/>
+                <a:ext cx="5150815" cy="4663440"/>
+              </a:xfrm>
+              <a:prstGeom prst="roundRect">
+                <a:avLst/>
+              </a:prstGeom>
+              <a:solidFill>
+                <a:srgbClr val="F4F8F5"/>
+              </a:solidFill>
+              <a:ln w="12700">
+                <a:solidFill>
+                  <a:srgbClr val="76927A"/>
+                </a:solidFill>
+              </a:ln>
+            </p:spPr>
+            <p:style>
+              <a:lnRef idx="1">
+                <a:schemeClr val="accent1"/>
+              </a:lnRef>
+              <a:fillRef idx="3">
+                <a:schemeClr val="accent1"/>
+              </a:fillRef>
+              <a:effectRef idx="2">
+                <a:schemeClr val="accent1"/>
+              </a:effectRef>
+              <a:fontRef idx="minor">
+                <a:schemeClr val="lt1"/>
+              </a:fontRef>
+            </p:style>
+            <p:txBody>
+              <a:bodyPr wrap="square" lIns="274320" tIns="274320" rIns="274320" rtlCol="0" anchor="ctr"/>
+              <a:lstStyle/>
+              <a:p>
+                <a:pPr algn="ctr">
+                  <a:defRPr sz="1800" b="1">
+                    <a:solidFill>
+                      <a:srgbClr val="113927"/>
+                    </a:solidFill>
+                    <a:latin typeface="Outfit"/>
+                  </a:defRPr>
+                </a:pPr>
+                <a:r>
+                  <a:rPr dirty="0"/>
+                  <a:t>¿</a:t>
+                </a:r>
+                <a:r>
+                  <a:rPr dirty="0" err="1"/>
+                  <a:t>Cómo</a:t>
+                </a:r>
+                <a:r>
+                  <a:rPr dirty="0"/>
+                  <a:t> </a:t>
+                </a:r>
+                <a:r>
+                  <a:rPr dirty="0" err="1"/>
+                  <a:t>Reducir</a:t>
+                </a:r>
+                <a:r>
+                  <a:rPr dirty="0"/>
+                  <a:t> la NAIRU sin </a:t>
+                </a:r>
+                <a:r>
+                  <a:rPr dirty="0" err="1"/>
+                  <a:t>Inflación</a:t>
+                </a:r>
+                <a:r>
+                  <a:rPr dirty="0"/>
+                  <a:t>?</a:t>
+                </a:r>
+              </a:p>
+              <a:p>
+                <a:pPr>
+                  <a:spcBef>
+                    <a:spcPts val="800"/>
+                  </a:spcBef>
+                  <a:defRPr sz="1600">
+                    <a:solidFill>
+                      <a:srgbClr val="2F3A30"/>
+                    </a:solidFill>
+                    <a:latin typeface="Calibri"/>
+                  </a:defRPr>
+                </a:pPr>
+                <a:r>
+                  <a:rPr dirty="0"/>
+                  <a:t>• </a:t>
+                </a:r>
+                <a:r>
+                  <a:rPr dirty="0" err="1"/>
+                  <a:t>Recordatorio</a:t>
+                </a:r>
+                <a:r>
+                  <a:rPr dirty="0"/>
+                  <a:t> de la </a:t>
+                </a:r>
+                <a:r>
+                  <a:rPr dirty="0" err="1"/>
+                  <a:t>Sesión</a:t>
+                </a:r>
+                <a:r>
+                  <a:rPr dirty="0"/>
+                  <a:t> 4: La </a:t>
+                </a:r>
+                <a:r>
+                  <a:rPr dirty="0" err="1"/>
+                  <a:t>tasa</a:t>
+                </a:r>
+                <a:r>
+                  <a:rPr dirty="0"/>
+                  <a:t> natural de </a:t>
+                </a:r>
+                <a:r>
+                  <a:rPr dirty="0" err="1"/>
+                  <a:t>desempleo</a:t>
+                </a:r>
+                <a:r>
+                  <a:rPr dirty="0"/>
+                  <a:t> </a:t>
+                </a:r>
+                <a:r>
+                  <a:rPr dirty="0" err="1"/>
+                  <a:t>viene</a:t>
+                </a:r>
+                <a:r>
+                  <a:rPr dirty="0"/>
+                  <a:t> dada </a:t>
+                </a:r>
+                <a:r>
+                  <a:rPr dirty="0" err="1"/>
+                  <a:t>por</a:t>
+                </a:r>
+                <a:r>
+                  <a:rPr dirty="0"/>
+                  <a:t> </a:t>
+                </a:r>
+                <a14:m>
+                  <m:oMath xmlns:m="http://schemas.openxmlformats.org/officeDocument/2006/math">
+                    <m:sSub>
+                      <m:sSubPr>
+                        <m:ctrlPr>
+                          <a:rPr lang="es-ES" i="1" dirty="0" smtClean="0">
+                            <a:latin typeface="Cambria Math" panose="02040503050406030204" pitchFamily="18" charset="0"/>
+                          </a:rPr>
+                        </m:ctrlPr>
+                      </m:sSubPr>
+                      <m:e>
+                        <m:r>
+                          <a:rPr lang="es-ES" i="1" dirty="0" smtClean="0">
+                            <a:latin typeface="Cambria Math" panose="02040503050406030204" pitchFamily="18" charset="0"/>
+                          </a:rPr>
+                          <m:t>𝑢</m:t>
+                        </m:r>
+                      </m:e>
+                      <m:sub>
+                        <m:r>
+                          <a:rPr lang="es-ES" i="1" dirty="0" smtClean="0">
+                            <a:latin typeface="Cambria Math" panose="02040503050406030204" pitchFamily="18" charset="0"/>
+                          </a:rPr>
+                          <m:t>𝑛</m:t>
+                        </m:r>
+                      </m:sub>
+                    </m:sSub>
+                    <m:r>
+                      <a:rPr lang="es-ES" i="1" dirty="0">
+                        <a:latin typeface="Cambria Math" panose="02040503050406030204" pitchFamily="18" charset="0"/>
+                      </a:rPr>
+                      <m:t>= </m:t>
+                    </m:r>
+                    <m:sSub>
+                      <m:sSubPr>
+                        <m:ctrlPr>
+                          <a:rPr lang="es-ES" i="1" dirty="0" err="1">
+                            <a:latin typeface="Cambria Math" panose="02040503050406030204" pitchFamily="18" charset="0"/>
+                          </a:rPr>
+                        </m:ctrlPr>
+                      </m:sSubPr>
+                      <m:e>
+                        <m:r>
+                          <a:rPr lang="es-ES" i="1" dirty="0" err="1">
+                            <a:latin typeface="Cambria Math" panose="02040503050406030204" pitchFamily="18" charset="0"/>
+                          </a:rPr>
+                          <m:t>𝑢</m:t>
+                        </m:r>
+                      </m:e>
+                      <m:sub>
+                        <m:r>
+                          <a:rPr lang="es-ES" i="1" dirty="0" err="1" smtClean="0">
+                            <a:latin typeface="Cambria Math" panose="02040503050406030204" pitchFamily="18" charset="0"/>
+                          </a:rPr>
+                          <m:t>𝑓</m:t>
+                        </m:r>
+                      </m:sub>
+                    </m:sSub>
+                    <m:r>
+                      <a:rPr lang="es-ES" i="1" dirty="0">
+                        <a:latin typeface="Cambria Math" panose="02040503050406030204" pitchFamily="18" charset="0"/>
+                      </a:rPr>
+                      <m:t>+ </m:t>
+                    </m:r>
+                    <m:sSub>
+                      <m:sSubPr>
+                        <m:ctrlPr>
+                          <a:rPr lang="es-ES" i="1" dirty="0" err="1">
+                            <a:latin typeface="Cambria Math" panose="02040503050406030204" pitchFamily="18" charset="0"/>
+                          </a:rPr>
+                        </m:ctrlPr>
+                      </m:sSubPr>
+                      <m:e>
+                        <m:r>
+                          <a:rPr lang="es-ES" i="1" dirty="0" err="1">
+                            <a:latin typeface="Cambria Math" panose="02040503050406030204" pitchFamily="18" charset="0"/>
+                          </a:rPr>
+                          <m:t>𝑢</m:t>
+                        </m:r>
+                      </m:e>
+                      <m:sub>
+                        <m:r>
+                          <a:rPr lang="es-ES" i="1" dirty="0" err="1" smtClean="0">
+                            <a:latin typeface="Cambria Math" panose="02040503050406030204" pitchFamily="18" charset="0"/>
+                          </a:rPr>
+                          <m:t>𝑒</m:t>
+                        </m:r>
+                      </m:sub>
+                    </m:sSub>
+                  </m:oMath>
+                </a14:m>
+                <a:r>
+                  <a:rPr dirty="0"/>
+                  <a:t>.</a:t>
+                </a:r>
+              </a:p>
+              <a:p>
+                <a:pPr>
+                  <a:spcBef>
+                    <a:spcPts val="800"/>
+                  </a:spcBef>
+                  <a:defRPr sz="1600">
+                    <a:solidFill>
+                      <a:srgbClr val="2F3A30"/>
+                    </a:solidFill>
+                    <a:latin typeface="Calibri"/>
+                  </a:defRPr>
+                </a:pPr>
+                <a:r>
+                  <a:rPr dirty="0"/>
+                  <a:t>• 1. </a:t>
+                </a:r>
+                <a:r>
+                  <a:rPr dirty="0" err="1"/>
+                  <a:t>Orientación</a:t>
+                </a:r>
+                <a:r>
+                  <a:rPr dirty="0"/>
+                  <a:t> e </a:t>
+                </a:r>
+                <a:r>
+                  <a:rPr dirty="0" err="1"/>
+                  <a:t>Intermediación</a:t>
+                </a:r>
+                <a:r>
+                  <a:rPr dirty="0"/>
+                  <a:t> Laboral: Reduce las </a:t>
+                </a:r>
+                <a:r>
+                  <a:rPr dirty="0" err="1"/>
+                  <a:t>asimetrías</a:t>
+                </a:r>
+                <a:r>
+                  <a:rPr dirty="0"/>
+                  <a:t> de </a:t>
+                </a:r>
+                <a:r>
+                  <a:rPr dirty="0" err="1"/>
+                  <a:t>información</a:t>
+                </a:r>
+                <a:r>
+                  <a:rPr dirty="0"/>
+                  <a:t> y </a:t>
+                </a:r>
+                <a:r>
+                  <a:rPr dirty="0" err="1"/>
+                  <a:t>los</a:t>
+                </a:r>
+                <a:r>
+                  <a:rPr dirty="0"/>
+                  <a:t> </a:t>
+                </a:r>
+                <a:r>
+                  <a:rPr dirty="0" err="1"/>
+                  <a:t>costes</a:t>
+                </a:r>
+                <a:r>
+                  <a:rPr dirty="0"/>
+                  <a:t> de </a:t>
+                </a:r>
+                <a:r>
+                  <a:rPr dirty="0" err="1"/>
+                  <a:t>búsqueda</a:t>
+                </a:r>
+                <a:r>
+                  <a:rPr dirty="0"/>
+                  <a:t> → reduce el </a:t>
+                </a:r>
+                <a:r>
+                  <a:rPr dirty="0" err="1"/>
+                  <a:t>paro</a:t>
+                </a:r>
+                <a:r>
+                  <a:rPr dirty="0"/>
+                  <a:t> </a:t>
+                </a:r>
+                <a:r>
+                  <a:rPr dirty="0" err="1"/>
+                  <a:t>friccional</a:t>
+                </a:r>
+                <a:r>
+                  <a:rPr dirty="0"/>
+                  <a:t>.</a:t>
+                </a:r>
+              </a:p>
+              <a:p>
+                <a:pPr>
+                  <a:spcBef>
+                    <a:spcPts val="800"/>
+                  </a:spcBef>
+                  <a:defRPr sz="1600">
+                    <a:solidFill>
+                      <a:srgbClr val="2F3A30"/>
+                    </a:solidFill>
+                    <a:latin typeface="Calibri"/>
+                  </a:defRPr>
+                </a:pPr>
+                <a:r>
+                  <a:rPr dirty="0"/>
+                  <a:t>• 2. </a:t>
+                </a:r>
+                <a:r>
+                  <a:rPr dirty="0" err="1"/>
+                  <a:t>Formación</a:t>
+                </a:r>
+                <a:r>
+                  <a:rPr dirty="0"/>
+                  <a:t> </a:t>
+                </a:r>
+                <a:r>
+                  <a:rPr dirty="0" err="1"/>
+                  <a:t>Profesional</a:t>
+                </a:r>
+                <a:r>
+                  <a:rPr dirty="0"/>
+                  <a:t> y Reskilling: </a:t>
+                </a:r>
+                <a:r>
+                  <a:rPr dirty="0" err="1"/>
+                  <a:t>Corrige</a:t>
+                </a:r>
+                <a:r>
+                  <a:rPr dirty="0"/>
+                  <a:t> el </a:t>
+                </a:r>
+                <a:r>
+                  <a:rPr dirty="0" err="1"/>
+                  <a:t>desajuste</a:t>
+                </a:r>
+                <a:r>
+                  <a:rPr dirty="0"/>
+                  <a:t> de </a:t>
+                </a:r>
+                <a:r>
+                  <a:rPr dirty="0" err="1"/>
+                  <a:t>habilidades</a:t>
+                </a:r>
+                <a:r>
+                  <a:rPr dirty="0"/>
+                  <a:t> (skills mismatch) → reduce el </a:t>
+                </a:r>
+                <a:r>
+                  <a:rPr dirty="0" err="1"/>
+                  <a:t>paro</a:t>
+                </a:r>
+                <a:r>
+                  <a:rPr dirty="0"/>
+                  <a:t> </a:t>
+                </a:r>
+                <a:r>
+                  <a:rPr dirty="0" err="1"/>
+                  <a:t>estructural</a:t>
+                </a:r>
+                <a:r>
+                  <a:rPr dirty="0"/>
+                  <a:t>.</a:t>
+                </a:r>
+              </a:p>
+              <a:p>
+                <a:pPr>
+                  <a:spcBef>
+                    <a:spcPts val="800"/>
+                  </a:spcBef>
+                  <a:defRPr sz="1600">
+                    <a:solidFill>
+                      <a:srgbClr val="2F3A30"/>
+                    </a:solidFill>
+                    <a:latin typeface="Calibri"/>
+                  </a:defRPr>
+                </a:pPr>
+                <a:r>
+                  <a:rPr dirty="0"/>
+                  <a:t>• 3. </a:t>
+                </a:r>
+                <a:r>
+                  <a:rPr dirty="0" err="1"/>
+                  <a:t>Resultado</a:t>
+                </a:r>
+                <a:r>
+                  <a:rPr dirty="0"/>
+                  <a:t> </a:t>
+                </a:r>
+                <a:r>
+                  <a:rPr dirty="0" err="1"/>
+                  <a:t>macroeconómico</a:t>
+                </a:r>
+                <a:r>
+                  <a:rPr dirty="0"/>
+                  <a:t> formal: El </a:t>
+                </a:r>
+                <a:r>
+                  <a:rPr dirty="0" err="1"/>
+                  <a:t>desempleo</a:t>
+                </a:r>
+                <a:r>
+                  <a:rPr dirty="0"/>
+                  <a:t> de </a:t>
+                </a:r>
+                <a:r>
+                  <a:rPr dirty="0" err="1"/>
+                  <a:t>equilibrio</a:t>
+                </a:r>
+                <a:r>
+                  <a:rPr dirty="0"/>
+                  <a:t> u* </a:t>
+                </a:r>
+                <a:r>
+                  <a:rPr dirty="0" err="1"/>
+                  <a:t>cae</a:t>
+                </a:r>
+                <a:r>
+                  <a:rPr dirty="0"/>
+                  <a:t> de forma </a:t>
+                </a:r>
+                <a:r>
+                  <a:rPr dirty="0" err="1"/>
+                  <a:t>permanente</a:t>
+                </a:r>
+                <a:r>
+                  <a:rPr dirty="0"/>
+                  <a:t> sin </a:t>
+                </a:r>
+                <a:r>
+                  <a:rPr dirty="0" err="1"/>
+                  <a:t>generar</a:t>
+                </a:r>
+                <a:r>
+                  <a:rPr dirty="0"/>
+                  <a:t> </a:t>
+                </a:r>
+                <a:r>
+                  <a:rPr dirty="0" err="1"/>
+                  <a:t>tensiones</a:t>
+                </a:r>
+                <a:r>
+                  <a:rPr dirty="0"/>
+                  <a:t> </a:t>
+                </a:r>
+                <a:r>
+                  <a:rPr dirty="0" err="1"/>
+                  <a:t>salariales</a:t>
+                </a:r>
+                <a:r>
+                  <a:rPr dirty="0"/>
+                  <a:t> </a:t>
+                </a:r>
+                <a:r>
+                  <a:rPr dirty="0" err="1"/>
+                  <a:t>ni</a:t>
+                </a:r>
+                <a:r>
+                  <a:rPr dirty="0"/>
+                  <a:t> </a:t>
+                </a:r>
+                <a:r>
+                  <a:rPr dirty="0" err="1"/>
+                  <a:t>aceleración</a:t>
+                </a:r>
+                <a:r>
+                  <a:rPr dirty="0"/>
+                  <a:t> </a:t>
+                </a:r>
+                <a:r>
+                  <a:rPr dirty="0" err="1"/>
+                  <a:t>inflacionista</a:t>
+                </a:r>
+                <a:r>
+                  <a:rPr dirty="0"/>
+                  <a:t>.</a:t>
+                </a:r>
+              </a:p>
+            </p:txBody>
+          </p:sp>
+        </mc:Choice>
+        <mc:Fallback>
+          <p:sp>
+            <p:nvSpPr>
+              <p:cNvPr id="5" name="Rounded Rectangle 4"/>
+              <p:cNvSpPr>
+                <a:spLocks noRot="1" noChangeAspect="1" noMove="1" noResize="1" noEditPoints="1" noAdjustHandles="1" noChangeArrowheads="1" noChangeShapeType="1" noTextEdit="1"/>
+              </p:cNvSpPr>
+              <p:nvPr/>
+            </p:nvSpPr>
+            <p:spPr>
+              <a:xfrm>
+                <a:off x="6309360" y="1645920"/>
+                <a:ext cx="5150815" cy="4663440"/>
+              </a:xfrm>
+              <a:prstGeom prst="roundRect">
+                <a:avLst/>
+              </a:prstGeom>
+              <a:blipFill>
+                <a:blip r:embed="rId2"/>
+                <a:stretch>
+                  <a:fillRect/>
+                </a:stretch>
+              </a:blipFill>
+              <a:ln w="12700">
+                <a:solidFill>
+                  <a:srgbClr val="76927A"/>
+                </a:solidFill>
+              </a:ln>
+            </p:spPr>
+            <p:txBody>
+              <a:bodyPr/>
+              <a:lstStyle/>
+              <a:p>
+                <a:r>
+                  <a:rPr lang="es-ES">
+                    <a:noFill/>
+                  </a:rPr>
+                  <a:t> </a:t>
+                </a:r>
+              </a:p>
+            </p:txBody>
+          </p:sp>
+        </mc:Fallback>
+      </mc:AlternateContent>
     </p:spTree>
   </p:cSld>
   <p:clrMapOvr>
@@ -7809,7 +9107,24 @@
               </a:defRPr>
             </a:pPr>
             <a:r>
-              <a:t>3. Incentivos a la Contratación (§3.3)</a:t>
+              <a:rPr dirty="0"/>
+              <a:t>3. </a:t>
+            </a:r>
+            <a:r>
+              <a:rPr dirty="0" err="1"/>
+              <a:t>Incentivos</a:t>
+            </a:r>
+            <a:r>
+              <a:rPr dirty="0"/>
+              <a:t> a la </a:t>
+            </a:r>
+            <a:r>
+              <a:rPr dirty="0" err="1"/>
+              <a:t>Contratación</a:t>
+            </a:r>
+            <a:r>
+              <a:rPr dirty="0"/>
+              <a:t> (§3.3)</a:t>
             </a:r>
           </a:p>
           <a:p>
@@ -7822,7 +9137,124 @@
               </a:defRPr>
             </a:pPr>
             <a:r>
-              <a:t>Bonificaciones en cotizaciones y subvenciones directas a contratos indefinidos. Estimulan la contratación pero generan elevado riesgo de peso muerto y sustitución.</a:t>
+              <a:rPr dirty="0" err="1"/>
+              <a:t>Bonificaciones</a:t>
+            </a:r>
+            <a:r>
+              <a:rPr dirty="0"/>
+              <a:t> </a:t>
+            </a:r>
+            <a:r>
+              <a:rPr dirty="0" err="1"/>
+              <a:t>en</a:t>
+            </a:r>
+            <a:r>
+              <a:rPr dirty="0"/>
+              <a:t> </a:t>
+            </a:r>
+            <a:r>
+              <a:rPr dirty="0" err="1"/>
+              <a:t>cotizaciones</a:t>
+            </a:r>
+            <a:r>
+              <a:rPr dirty="0"/>
+              <a:t> y </a:t>
+            </a:r>
+            <a:r>
+              <a:rPr dirty="0" err="1"/>
+              <a:t>subvenciones</a:t>
+            </a:r>
+            <a:r>
+              <a:rPr dirty="0"/>
+              <a:t> </a:t>
+            </a:r>
+            <a:r>
+              <a:rPr dirty="0" err="1"/>
+              <a:t>directas</a:t>
+            </a:r>
+            <a:r>
+              <a:rPr dirty="0"/>
+              <a:t> a </a:t>
+            </a:r>
+            <a:r>
+              <a:rPr dirty="0" err="1"/>
+              <a:t>contratos</a:t>
+            </a:r>
+            <a:r>
+              <a:rPr dirty="0"/>
+              <a:t> </a:t>
+            </a:r>
+            <a:r>
+              <a:rPr dirty="0" err="1"/>
+              <a:t>indefinidos</a:t>
+            </a:r>
+            <a:r>
+              <a:rPr dirty="0"/>
+              <a:t>. </a:t>
+            </a:r>
+            <a:r>
+              <a:rPr dirty="0" err="1"/>
+              <a:t>Estimulan</a:t>
+            </a:r>
+            <a:r>
+              <a:rPr dirty="0"/>
+              <a:t> la </a:t>
+            </a:r>
+            <a:r>
+              <a:rPr lang="es-ES" dirty="0"/>
+              <a:t>contratación,</a:t>
+            </a:r>
+            <a:r>
+              <a:rPr dirty="0"/>
+              <a:t> </a:t>
+            </a:r>
+            <a:r>
+              <a:rPr dirty="0" err="1"/>
+              <a:t>pero</a:t>
+            </a:r>
+            <a:r>
+              <a:rPr dirty="0"/>
+              <a:t> </a:t>
+            </a:r>
+            <a:r>
+              <a:rPr dirty="0" err="1"/>
+              <a:t>generan</a:t>
+            </a:r>
+            <a:r>
+              <a:rPr dirty="0"/>
+              <a:t> </a:t>
+            </a:r>
+            <a:r>
+              <a:rPr dirty="0" err="1"/>
+              <a:t>elevado</a:t>
+            </a:r>
+            <a:r>
+              <a:rPr dirty="0"/>
+              <a:t> </a:t>
+            </a:r>
+            <a:r>
+              <a:rPr dirty="0" err="1"/>
+              <a:t>riesgo</a:t>
+            </a:r>
+            <a:r>
+              <a:rPr dirty="0"/>
+              <a:t> de peso </a:t>
+            </a:r>
+            <a:r>
+              <a:rPr dirty="0" err="1"/>
+              <a:t>muerto</a:t>
+            </a:r>
+            <a:r>
+              <a:rPr dirty="0"/>
+              <a:t> y </a:t>
+            </a:r>
+            <a:r>
+              <a:rPr dirty="0" err="1"/>
+              <a:t>sustitución</a:t>
+            </a:r>
+            <a:r>
+              <a:rPr dirty="0"/>
+              <a:t>.</a:t>
             </a:r>
           </a:p>
         </p:txBody>
@@ -7945,7 +9377,16 @@
               </a:defRPr>
             </a:pPr>
             <a:r>
-              <a:t>5. Creación Directa de Empleo Público (§3.5)</a:t>
+              <a:rPr dirty="0"/>
+              <a:t>5. </a:t>
+            </a:r>
+            <a:r>
+              <a:rPr dirty="0" err="1"/>
+              <a:t>Creación</a:t>
+            </a:r>
+            <a:r>
+              <a:rPr dirty="0"/>
+              <a:t> Directa de Empleo Público (§3.5)</a:t>
             </a:r>
           </a:p>
           <a:p>
@@ -7958,7 +9399,104 @@
               </a:defRPr>
             </a:pPr>
             <a:r>
-              <a:t>Planes de empleo municipal y obras comunitarias. Alivio temporal a corto plazo pero con nulo impacto en capital humano y riesgo de efecto estigma.</a:t>
+              <a:rPr dirty="0"/>
+              <a:t>Planes de </a:t>
+            </a:r>
+            <a:r>
+              <a:rPr dirty="0" err="1"/>
+              <a:t>empleo</a:t>
+            </a:r>
+            <a:r>
+              <a:rPr dirty="0"/>
+              <a:t> municipal y </a:t>
+            </a:r>
+            <a:r>
+              <a:rPr dirty="0" err="1"/>
+              <a:t>obras</a:t>
+            </a:r>
+            <a:r>
+              <a:rPr dirty="0"/>
+              <a:t> </a:t>
+            </a:r>
+            <a:r>
+              <a:rPr dirty="0" err="1"/>
+              <a:t>comunitarias</a:t>
+            </a:r>
+            <a:r>
+              <a:rPr dirty="0"/>
+              <a:t>. Alivio temporal a corto </a:t>
+            </a:r>
+            <a:r>
+              <a:rPr lang="es-ES" dirty="0"/>
+              <a:t>plazo,</a:t>
+            </a:r>
+            <a:r>
+              <a:rPr dirty="0"/>
+              <a:t> </a:t>
+            </a:r>
+            <a:r>
+              <a:rPr dirty="0" err="1"/>
+              <a:t>pero</a:t>
+            </a:r>
+            <a:r>
+              <a:rPr dirty="0"/>
+              <a:t> con </a:t>
+            </a:r>
+            <a:r>
+              <a:rPr dirty="0" err="1"/>
+              <a:t>nulo</a:t>
+            </a:r>
+            <a:r>
+              <a:rPr dirty="0"/>
+              <a:t> </a:t>
+            </a:r>
+            <a:r>
+              <a:rPr dirty="0" err="1"/>
+              <a:t>impacto</a:t>
+            </a:r>
+            <a:r>
+              <a:rPr dirty="0"/>
+              <a:t> </a:t>
+            </a:r>
+            <a:r>
+              <a:rPr dirty="0" err="1"/>
+              <a:t>en</a:t>
+            </a:r>
+            <a:r>
+              <a:rPr dirty="0"/>
+              <a:t> capital </a:t>
+            </a:r>
+            <a:r>
+              <a:rPr dirty="0" err="1"/>
+              <a:t>humano</a:t>
+            </a:r>
+            <a:r>
+              <a:rPr dirty="0"/>
+              <a:t> y </a:t>
+            </a:r>
+            <a:r>
+              <a:rPr dirty="0" err="1"/>
+              <a:t>riesgo</a:t>
+            </a:r>
+            <a:r>
+              <a:rPr dirty="0"/>
+              <a:t> de </a:t>
+            </a:r>
+            <a:r>
+              <a:rPr dirty="0" err="1"/>
+              <a:t>efecto</a:t>
+            </a:r>
+            <a:r>
+              <a:rPr dirty="0"/>
+              <a:t> </a:t>
+            </a:r>
+            <a:r>
+              <a:rPr dirty="0" err="1"/>
+              <a:t>estigma</a:t>
+            </a:r>
+            <a:r>
+              <a:rPr dirty="0"/>
+              <a:t>.</a:t>
             </a:r>
           </a:p>
         </p:txBody>
@@ -8221,8 +9759,18 @@
               </a:defRPr>
             </a:pPr>
             <a:r>
-              <a:t>Efecto Sustitución</a:t>
-            </a:r>
+              <a:rPr dirty="0" err="1"/>
+              <a:t>Efecto</a:t>
+            </a:r>
+            <a:r>
+              <a:rPr dirty="0"/>
+              <a:t> </a:t>
+            </a:r>
+            <a:r>
+              <a:rPr dirty="0" err="1"/>
+              <a:t>Sustitución</a:t>
+            </a:r>
+            <a:endParaRPr dirty="0"/>
           </a:p>
           <a:p>
             <a:pPr>
@@ -8237,7 +9785,120 @@
               </a:defRPr>
             </a:pPr>
             <a:r>
-              <a:t>La empresa decide contratar a un trabajador que cumple los requisitos de la subvención despidiendo o no renovando a otro empleado que no genera bonificación.</a:t>
+              <a:rPr dirty="0"/>
+              <a:t>La </a:t>
+            </a:r>
+            <a:r>
+              <a:rPr dirty="0" err="1"/>
+              <a:t>empresa</a:t>
+            </a:r>
+            <a:r>
+              <a:rPr dirty="0"/>
+              <a:t> decide </a:t>
+            </a:r>
+            <a:r>
+              <a:rPr dirty="0" err="1"/>
+              <a:t>contratar</a:t>
+            </a:r>
+            <a:r>
+              <a:rPr dirty="0"/>
+              <a:t> a un </a:t>
+            </a:r>
+            <a:r>
+              <a:rPr dirty="0" err="1"/>
+              <a:t>trabajador</a:t>
+            </a:r>
+            <a:r>
+              <a:rPr dirty="0"/>
+              <a:t> </a:t>
+            </a:r>
+            <a:r>
+              <a:rPr dirty="0" err="1"/>
+              <a:t>que</a:t>
+            </a:r>
+            <a:r>
+              <a:rPr dirty="0"/>
+              <a:t> </a:t>
+            </a:r>
+            <a:r>
+              <a:rPr dirty="0" err="1"/>
+              <a:t>cumple</a:t>
+            </a:r>
+            <a:r>
+              <a:rPr dirty="0"/>
+              <a:t> </a:t>
+            </a:r>
+            <a:r>
+              <a:rPr dirty="0" err="1"/>
+              <a:t>los</a:t>
+            </a:r>
+            <a:r>
+              <a:rPr dirty="0"/>
+              <a:t> </a:t>
+            </a:r>
+            <a:r>
+              <a:rPr dirty="0" err="1"/>
+              <a:t>requisitos</a:t>
+            </a:r>
+            <a:r>
+              <a:rPr dirty="0"/>
+              <a:t> de la </a:t>
+            </a:r>
+            <a:r>
+              <a:rPr dirty="0" err="1"/>
+              <a:t>subvención</a:t>
+            </a:r>
+            <a:r>
+              <a:rPr dirty="0"/>
+              <a:t> </a:t>
+            </a:r>
+            <a:r>
+              <a:rPr dirty="0" err="1"/>
+              <a:t>despidiendo</a:t>
+            </a:r>
+            <a:r>
+              <a:rPr dirty="0"/>
+              <a:t> o no </a:t>
+            </a:r>
+            <a:r>
+              <a:rPr dirty="0" err="1"/>
+              <a:t>renovando</a:t>
+            </a:r>
+            <a:r>
+              <a:rPr dirty="0"/>
+              <a:t> a </a:t>
+            </a:r>
+            <a:r>
+              <a:rPr dirty="0" err="1"/>
+              <a:t>otro</a:t>
+            </a:r>
+            <a:r>
+              <a:rPr dirty="0"/>
+              <a:t> </a:t>
+            </a:r>
+            <a:r>
+              <a:rPr dirty="0" err="1"/>
+              <a:t>empleado</a:t>
+            </a:r>
+            <a:r>
+              <a:rPr dirty="0"/>
+              <a:t> </a:t>
+            </a:r>
+            <a:r>
+              <a:rPr dirty="0" err="1"/>
+              <a:t>que</a:t>
+            </a:r>
+            <a:r>
+              <a:rPr dirty="0"/>
+              <a:t> no genera </a:t>
+            </a:r>
+            <a:r>
+              <a:rPr dirty="0" err="1"/>
+              <a:t>bonificación</a:t>
+            </a:r>
+            <a:r>
+              <a:rPr dirty="0"/>
+              <a:t>.</a:t>
             </a:r>
           </a:p>
           <a:p>
@@ -8253,7 +9914,100 @@
               </a:defRPr>
             </a:pPr>
             <a:r>
-              <a:t>Resultado neto nulo: Se cambia el rostro del desempleado pero no se crea ningún puesto de trabajo adicional en la economía.</a:t>
+              <a:rPr dirty="0" err="1"/>
+              <a:t>Resultado</a:t>
+            </a:r>
+            <a:r>
+              <a:rPr dirty="0"/>
+              <a:t> </a:t>
+            </a:r>
+            <a:r>
+              <a:rPr dirty="0" err="1"/>
+              <a:t>neto</a:t>
+            </a:r>
+            <a:r>
+              <a:rPr dirty="0"/>
+              <a:t> </a:t>
+            </a:r>
+            <a:r>
+              <a:rPr dirty="0" err="1"/>
+              <a:t>nulo</a:t>
+            </a:r>
+            <a:r>
+              <a:rPr dirty="0"/>
+              <a:t>: Se cambia el rostro del </a:t>
+            </a:r>
+            <a:r>
+              <a:rPr lang="es-ES" dirty="0"/>
+              <a:t>desempleado,</a:t>
+            </a:r>
+            <a:r>
+              <a:rPr dirty="0"/>
+              <a:t> </a:t>
+            </a:r>
+            <a:r>
+              <a:rPr dirty="0" err="1"/>
+              <a:t>pero</a:t>
+            </a:r>
+            <a:r>
+              <a:rPr dirty="0"/>
+              <a:t> no se </a:t>
+            </a:r>
+            <a:r>
+              <a:rPr dirty="0" err="1"/>
+              <a:t>crea</a:t>
+            </a:r>
+            <a:r>
+              <a:rPr dirty="0"/>
+              <a:t> </a:t>
+            </a:r>
+            <a:r>
+              <a:rPr dirty="0" err="1"/>
+              <a:t>ningún</a:t>
+            </a:r>
+            <a:r>
+              <a:rPr dirty="0"/>
+              <a:t> </a:t>
+            </a:r>
+            <a:r>
+              <a:rPr dirty="0" err="1"/>
+              <a:t>puesto</a:t>
+            </a:r>
+            <a:r>
+              <a:rPr dirty="0"/>
+              <a:t> de </a:t>
+            </a:r>
+            <a:r>
+              <a:rPr dirty="0" err="1"/>
+              <a:t>trabajo</a:t>
+            </a:r>
+            <a:r>
+              <a:rPr dirty="0"/>
+              <a:t> </a:t>
+            </a:r>
+            <a:r>
+              <a:rPr dirty="0" err="1"/>
+              <a:t>adicional</a:t>
+            </a:r>
+            <a:r>
+              <a:rPr dirty="0"/>
+              <a:t> </a:t>
+            </a:r>
+            <a:r>
+              <a:rPr dirty="0" err="1"/>
+              <a:t>en</a:t>
+            </a:r>
+            <a:r>
+              <a:rPr dirty="0"/>
+              <a:t> la </a:t>
+            </a:r>
+            <a:r>
+              <a:rPr dirty="0" err="1"/>
+              <a:t>economía</a:t>
+            </a:r>
+            <a:r>
+              <a:rPr dirty="0"/>
+              <a:t>.</a:t>
             </a:r>
           </a:p>
         </p:txBody>

</xml_diff>